<commit_message>
Prototype: animated role picker, motion, time-based greeting; deck update
- Sign-in: five animated role cards (gold highlight, toggle, 3D tilt,
  staggered entrance, keyboard and arrow buttons); PIN fills in, wrong
  PIN shakes, sign-in fades out. Website "Try as" buttons preselect.
- Greeting and briefing title follow the time of day (morning,
  afternoon, evening, late night); Gemini gets the time of day too.
- Sliding gold highlight on the sidebar, map-mode tabs and replay
  switch; views and map modes fade in; buttons press in.
- Gold cursor ring with trailing ripples and click ripples (off with
  reduced motion).
- Home page hero: grid bends around the cursor and lights up near it.
- Phones: dashboard columns can shrink, so the page no longer overflows.
- Deck: 14 slides with live screenshots (do-no-harm, AI suggestion,
  stress test, ripple replay, AI at every step), real figures, stack,
  links and speaker notes.
</commit_message>
<xml_diff>
--- a/docs/DisruptionIQ_Overclock26.pptx
+++ b/docs/DisruptionIQ_Overclock26.pptx
@@ -12,6 +12,9 @@
     <p:sldId id="260" r:id="rId6"/>
     <p:sldId id="261" r:id="rId7"/>
     <p:sldId id="262" r:id="rId8"/>
+    <p:sldId id="267" r:id="rId18"/>
+    <p:sldId id="268" r:id="rId19"/>
+    <p:sldId id="269" r:id="rId20"/>
     <p:sldId id="263" r:id="rId9"/>
     <p:sldId id="264" r:id="rId10"/>
     <p:sldId id="265" r:id="rId11"/>
@@ -648,7 +651,7 @@
           <a:p>
             <a:r>
               <a:rPr lang="en-US" dirty="0"/>
-              <a:t>In our demo, alert to ranked plan took [time], and exposure went from [₹ before] to [₹ after] once the plan was approved. Next: real carrier feeds, supplier reliability learned from history, and multi-warehouse optimisation. Thank you.</a:t>
+              <a:t>In the demo, an alert becomes checked, ranked recovery options in under five seconds, and the ripple replay shows ₹15.6 lakh lost in a week if nobody acts, against zero with the fixes. Next: live carrier and ERP data, a delay-prediction model trained on our risk dataset, and spending limits with WhatsApp approvals. Thank you.</a:t>
             </a:r>
             <a:endParaRPr lang="en-US" dirty="0"/>
           </a:p>
@@ -736,7 +739,7 @@
           <a:p>
             <a:r>
               <a:rPr lang="en-US" dirty="0"/>
-              <a:t>Backup for architecture questions. It is one app, one database and one rules engine; the AI layer is called only from the server and its output is checked against the options the rules built. Planned stack shown here [CONFIRM FINAL STACK].</a:t>
+              <a:t>Backup for architecture questions. The full app is one Next.js app, one PostgreSQL database and one rules engine; the live demo runs the same rules in the browser. Gemini is called only from a Vercel server function that keeps the key secret, and its picks are checked against the options the rules built.</a:t>
             </a:r>
             <a:endParaRPr lang="en-US" dirty="0"/>
           </a:p>
@@ -760,6 +763,270 @@
             <a:fld id="{F7021451-1387-4CA6-816F-3879F97B5CBC}" type="slidenum">
               <a:rPr lang="en-US"/>
               <a:t>11</a:t>
+            </a:fld>
+            <a:endParaRPr lang="en-US"/>
+          </a:p>
+        </p:txBody>
+      </p:sp>
+    </p:spTree>
+    <p:extLst>
+      <p:ext uri="{BB962C8B-B14F-4D97-AF65-F5344CB8AC3E}">
+        <p14:creationId xmlns:p14="http://schemas.microsoft.com/office/powerpoint/2010/main" val="1024086991"/>
+      </p:ext>
+    </p:extLst>
+  </p:cSld>
+  <p:clrMapOvr>
+    <a:masterClrMapping/>
+  </p:clrMapOvr>
+</p:notes>
+</file>
+
+<file path=ppt/notesSlides/notesSlide12.xml><?xml version="1.0" encoding="utf-8"?>
+<p:notes xmlns:a="http://schemas.openxmlformats.org/drawingml/2006/main" xmlns:r="http://schemas.openxmlformats.org/officeDocument/2006/relationships" xmlns:p="http://schemas.openxmlformats.org/presentationml/2006/main">
+  <p:cSld>
+    <p:spTree>
+      <p:nvGrpSpPr>
+        <p:cNvPr id="1" name=""/>
+        <p:cNvGrpSpPr/>
+        <p:nvPr/>
+      </p:nvGrpSpPr>
+      <p:grpSpPr>
+        <a:xfrm>
+          <a:off x="0" y="0"/>
+          <a:ext cx="0" cy="0"/>
+          <a:chOff x="0" y="0"/>
+          <a:chExt cx="0" cy="0"/>
+        </a:xfrm>
+      </p:grpSpPr>
+      <p:sp>
+        <p:nvSpPr>
+          <p:cNvPr id="2" name="Slide Image Placeholder 1"/>
+          <p:cNvSpPr>
+            <a:spLocks noGrp="1" noRot="1" noChangeAspect="1"/>
+          </p:cNvSpPr>
+          <p:nvPr>
+            <p:ph type="sldImg"/>
+          </p:nvPr>
+        </p:nvSpPr>
+        <p:spPr/>
+      </p:sp>
+      <p:sp>
+        <p:nvSpPr>
+          <p:cNvPr id="3" name="Notes Placeholder 2"/>
+          <p:cNvSpPr>
+            <a:spLocks noGrp="1"/>
+          </p:cNvSpPr>
+          <p:nvPr>
+            <p:ph type="body" idx="1"/>
+          </p:nvPr>
+        </p:nvSpPr>
+        <p:spPr/>
+        <p:txBody>
+          <a:bodyPr/>
+          <a:lstStyle/>
+          <a:p>
+            <a:r>
+              <a:rPr lang="en-US" dirty="0"/>
+              <a:t>Most tools tell you what broke. The stress test breaks the network on purpose, in simulation: every warehouse and supplier fails for a week, one at a time, and the rules measure the damage. Mumbai is the weakest point, with ₹12 lakh of orders and two with no backup; the suggested fix is buffer stock of the control unit in Hyderabad. It is chaos engineering applied to a supply chain.</a:t>
+            </a:r>
+            <a:endParaRPr lang="en-US" dirty="0"/>
+          </a:p>
+        </p:txBody>
+      </p:sp>
+      <p:sp>
+        <p:nvSpPr>
+          <p:cNvPr id="4" name="Slide Number Placeholder 3"/>
+          <p:cNvSpPr>
+            <a:spLocks noGrp="1"/>
+          </p:cNvSpPr>
+          <p:nvPr>
+            <p:ph type="sldNum" sz="quarter" idx="10"/>
+          </p:nvPr>
+        </p:nvSpPr>
+        <p:spPr/>
+        <p:txBody>
+          <a:bodyPr/>
+          <a:lstStyle/>
+          <a:p>
+            <a:fld id="{F7021451-1387-4CA6-816F-3879F97B5CBC}" type="slidenum">
+              <a:rPr lang="en-US"/>
+              <a:t>6</a:t>
+            </a:fld>
+            <a:endParaRPr lang="en-US"/>
+          </a:p>
+        </p:txBody>
+      </p:sp>
+    </p:spTree>
+    <p:extLst>
+      <p:ext uri="{BB962C8B-B14F-4D97-AF65-F5344CB8AC3E}">
+        <p14:creationId xmlns:p14="http://schemas.microsoft.com/office/powerpoint/2010/main" val="1024086991"/>
+      </p:ext>
+    </p:extLst>
+  </p:cSld>
+  <p:clrMapOvr>
+    <a:masterClrMapping/>
+  </p:clrMapOvr>
+</p:notes>
+</file>
+
+<file path=ppt/notesSlides/notesSlide13.xml><?xml version="1.0" encoding="utf-8"?>
+<p:notes xmlns:a="http://schemas.openxmlformats.org/drawingml/2006/main" xmlns:r="http://schemas.openxmlformats.org/officeDocument/2006/relationships" xmlns:p="http://schemas.openxmlformats.org/presentationml/2006/main">
+  <p:cSld>
+    <p:spTree>
+      <p:nvGrpSpPr>
+        <p:cNvPr id="1" name=""/>
+        <p:cNvGrpSpPr/>
+        <p:nvPr/>
+      </p:nvGrpSpPr>
+      <p:grpSpPr>
+        <a:xfrm>
+          <a:off x="0" y="0"/>
+          <a:ext cx="0" cy="0"/>
+          <a:chOff x="0" y="0"/>
+          <a:chExt cx="0" cy="0"/>
+        </a:xfrm>
+      </p:grpSpPr>
+      <p:sp>
+        <p:nvSpPr>
+          <p:cNvPr id="2" name="Slide Image Placeholder 1"/>
+          <p:cNvSpPr>
+            <a:spLocks noGrp="1" noRot="1" noChangeAspect="1"/>
+          </p:cNvSpPr>
+          <p:nvPr>
+            <p:ph type="sldImg"/>
+          </p:nvPr>
+        </p:nvSpPr>
+        <p:spPr/>
+      </p:sp>
+      <p:sp>
+        <p:nvSpPr>
+          <p:cNvPr id="3" name="Notes Placeholder 2"/>
+          <p:cNvSpPr>
+            <a:spLocks noGrp="1"/>
+          </p:cNvSpPr>
+          <p:nvPr>
+            <p:ph type="body" idx="1"/>
+          </p:nvPr>
+        </p:nvSpPr>
+        <p:spPr/>
+        <p:txBody>
+          <a:bodyPr/>
+          <a:lstStyle/>
+          <a:p>
+            <a:r>
+              <a:rPr lang="en-US" dirty="0"/>
+              <a:t>Ripple replay shows the cost of waiting. Drag through the next seven days: if nobody acts, Nova Medical's order is missed on day three, fixes expire as transit time runs out, and ₹15.6 lakh is lost by day seven. Switch to 'with suggested fixes' and the loss stays at zero.</a:t>
+            </a:r>
+            <a:endParaRPr lang="en-US" dirty="0"/>
+          </a:p>
+        </p:txBody>
+      </p:sp>
+      <p:sp>
+        <p:nvSpPr>
+          <p:cNvPr id="4" name="Slide Number Placeholder 3"/>
+          <p:cNvSpPr>
+            <a:spLocks noGrp="1"/>
+          </p:cNvSpPr>
+          <p:nvPr>
+            <p:ph type="sldNum" sz="quarter" idx="10"/>
+          </p:nvPr>
+        </p:nvSpPr>
+        <p:spPr/>
+        <p:txBody>
+          <a:bodyPr/>
+          <a:lstStyle/>
+          <a:p>
+            <a:fld id="{F7021451-1387-4CA6-816F-3879F97B5CBC}" type="slidenum">
+              <a:rPr lang="en-US"/>
+              <a:t>6</a:t>
+            </a:fld>
+            <a:endParaRPr lang="en-US"/>
+          </a:p>
+        </p:txBody>
+      </p:sp>
+    </p:spTree>
+    <p:extLst>
+      <p:ext uri="{BB962C8B-B14F-4D97-AF65-F5344CB8AC3E}">
+        <p14:creationId xmlns:p14="http://schemas.microsoft.com/office/powerpoint/2010/main" val="1024086991"/>
+      </p:ext>
+    </p:extLst>
+  </p:cSld>
+  <p:clrMapOvr>
+    <a:masterClrMapping/>
+  </p:clrMapOvr>
+</p:notes>
+</file>
+
+<file path=ppt/notesSlides/notesSlide14.xml><?xml version="1.0" encoding="utf-8"?>
+<p:notes xmlns:a="http://schemas.openxmlformats.org/drawingml/2006/main" xmlns:r="http://schemas.openxmlformats.org/officeDocument/2006/relationships" xmlns:p="http://schemas.openxmlformats.org/presentationml/2006/main">
+  <p:cSld>
+    <p:spTree>
+      <p:nvGrpSpPr>
+        <p:cNvPr id="1" name=""/>
+        <p:cNvGrpSpPr/>
+        <p:nvPr/>
+      </p:nvGrpSpPr>
+      <p:grpSpPr>
+        <a:xfrm>
+          <a:off x="0" y="0"/>
+          <a:ext cx="0" cy="0"/>
+          <a:chOff x="0" y="0"/>
+          <a:chExt cx="0" cy="0"/>
+        </a:xfrm>
+      </p:grpSpPr>
+      <p:sp>
+        <p:nvSpPr>
+          <p:cNvPr id="2" name="Slide Image Placeholder 1"/>
+          <p:cNvSpPr>
+            <a:spLocks noGrp="1" noRot="1" noChangeAspect="1"/>
+          </p:cNvSpPr>
+          <p:nvPr>
+            <p:ph type="sldImg"/>
+          </p:nvPr>
+        </p:nvSpPr>
+        <p:spPr/>
+      </p:sp>
+      <p:sp>
+        <p:nvSpPr>
+          <p:cNvPr id="3" name="Notes Placeholder 2"/>
+          <p:cNvSpPr>
+            <a:spLocks noGrp="1"/>
+          </p:cNvSpPr>
+          <p:nvPr>
+            <p:ph type="body" idx="1"/>
+          </p:nvPr>
+        </p:nvSpPr>
+        <p:spPr/>
+        <p:txBody>
+          <a:bodyPr/>
+          <a:lstStyle/>
+          <a:p>
+            <a:r>
+              <a:rPr lang="en-US" dirty="0"/>
+              <a:t>Gemini 3.5 Flash-Lite works at every step: a morning briefing written for each role, a plain-English summary for the approver of what a plan commits to and what to check, and an incident report written automatically when a disruption is resolved and saved to the audit log. The rules work out every number; the AI only writes the words.</a:t>
+            </a:r>
+            <a:endParaRPr lang="en-US" dirty="0"/>
+          </a:p>
+        </p:txBody>
+      </p:sp>
+      <p:sp>
+        <p:nvSpPr>
+          <p:cNvPr id="4" name="Slide Number Placeholder 3"/>
+          <p:cNvSpPr>
+            <a:spLocks noGrp="1"/>
+          </p:cNvSpPr>
+          <p:nvPr>
+            <p:ph type="sldNum" sz="quarter" idx="10"/>
+          </p:nvPr>
+        </p:nvSpPr>
+        <p:spPr/>
+        <p:txBody>
+          <a:bodyPr/>
+          <a:lstStyle/>
+          <a:p>
+            <a:fld id="{F7021451-1387-4CA6-816F-3879F97B5CBC}" type="slidenum">
+              <a:rPr lang="en-US"/>
+              <a:t>6</a:t>
             </a:fld>
             <a:endParaRPr lang="en-US"/>
           </a:p>
@@ -1088,7 +1355,7 @@
           <a:p>
             <a:r>
               <a:rPr lang="en-US" dirty="0"/>
-              <a:t>Two disruptions that need very different fixes. A port strike can be solved with stock we already hold; a factory outage needs a new supplier. This is where we switch to the live demo and press the chaos button.</a:t>
+              <a:t>These are the two disruptions in the live demo. A sea-freight delay at Chennai Port puts three orders worth ₹8.9 lakh at risk; a supplier shortfall in Mumbai hits three more worth ₹12 lakh. Watch the do-no-harm check: for Chennai it skips a stock source that would starve another order, and in Mumbai the free split options are flagged because each would starve the other.</a:t>
             </a:r>
             <a:endParaRPr lang="en-US" dirty="0"/>
           </a:p>
@@ -1176,7 +1443,7 @@
           <a:p>
             <a:r>
               <a:rPr lang="en-US" dirty="0"/>
-              <a:t>Every affected order gets a risk score, and the score shows its working. You can see how much comes from slack, shortage size, customer tier, penalty exposure and supplier reliability, so nobody has to trust a black box.</a:t>
+              <a:t>This is our novelty. Other tools judge a fix only by whether it saves the order in front of them. DisruptionIQ checks what every fix would take from other orders before anyone sees it. Here, the free option of splitting Nova Medical's order would leave Pioneer Labs six units short, so it is flagged in red and ranked last, and the map shows the harm. For the Chennai delay, Chennai was skipped as a stock source for the same reason. The approver sees the check again with today's stock.</a:t>
             </a:r>
             <a:endParaRPr lang="en-US" dirty="0"/>
           </a:p>
@@ -1264,7 +1531,7 @@
           <a:p>
             <a:r>
               <a:rPr lang="en-US" dirty="0"/>
-              <a:t>The rules engine builds the recovery options from real stock, suppliers and deadlines. AI explains the trade-offs in cost, speed and orders saved, but it can only pick from that list, so it cannot invent stock or a supplier.</a:t>
+              <a:t>The rules built nine options for the Mumbai disruption and checked each one for side effects. Gemini reads them and recommends one per order; the page highlights its picks as AI suggested, with one-click select buttons. Gemini can only pick option numbers that exist, and if the AI is unavailable the rules' own pick is shown instead. A person still submits, and another person approves.</a:t>
             </a:r>
             <a:endParaRPr lang="en-US" dirty="0"/>
           </a:p>
@@ -1440,7 +1707,7 @@
           <a:p>
             <a:r>
               <a:rPr lang="en-US" dirty="0"/>
-              <a:t>What sets us apart: AI with guardrails, risk scores that show their reasons, and a chaos button that proves the safety rules live in front of you. [CONFIRM BUILT: drop any feature we did not build.]</a:t>
+              <a:t>What sets us apart: AI with guardrails, a do-no-harm check on every fix, a chaos button that proves the safety rules live, visible separation of duties and a stock recheck before execution. Also live in the demo: the stress test, the ripple replay and a map preview of every fix.</a:t>
             </a:r>
             <a:endParaRPr lang="en-US" dirty="0"/>
           </a:p>
@@ -3125,14 +3392,11 @@
                 <a:solidFill>
                   <a:schemeClr val="tx1"/>
                 </a:solidFill>
-                <a:highlight>
-                  <a:srgbClr val="FFFF00"/>
-                </a:highlight>
                 <a:latin typeface="+mj-lt" pitchFamily="34" charset="0"/>
                 <a:ea typeface="+mj-lt" pitchFamily="34" charset="-122"/>
                 <a:cs typeface="+mj-lt" pitchFamily="34" charset="-120"/>
               </a:rPr>
-              <a:t>[time]</a:t>
+              <a:t>&lt; 5 s</a:t>
             </a:r>
             <a:endParaRPr lang="en-US" sz="2400" dirty="0"/>
           </a:p>
@@ -3168,7 +3432,7 @@
                   <a:schemeClr val="accent2"/>
                 </a:solidFill>
               </a:rPr>
-              <a:t>Alert → ranked plan</a:t>
+              <a:t>Alert → checked, ranked options</a:t>
             </a:r>
             <a:endParaRPr lang="en-US" sz="1400" dirty="0"/>
           </a:p>
@@ -3203,45 +3467,11 @@
                 <a:solidFill>
                   <a:schemeClr val="tx1"/>
                 </a:solidFill>
-                <a:highlight>
-                  <a:srgbClr val="FFFF00"/>
-                </a:highlight>
                 <a:latin typeface="+mj-lt" pitchFamily="34" charset="0"/>
                 <a:ea typeface="+mj-lt" pitchFamily="34" charset="-122"/>
                 <a:cs typeface="+mj-lt" pitchFamily="34" charset="-120"/>
               </a:rPr>
-              <a:t>[₹ before]</a:t>
-            </a:r>
-            <a:pPr indent="0" marL="0">
-              <a:buNone/>
-            </a:pPr>
-            <a:r>
-              <a:rPr lang="en-US" sz="2400" b="1" dirty="0">
-                <a:solidFill>
-                  <a:schemeClr val="tx1"/>
-                </a:solidFill>
-                <a:latin typeface="+mj-lt" pitchFamily="34" charset="0"/>
-                <a:ea typeface="+mj-lt" pitchFamily="34" charset="-122"/>
-                <a:cs typeface="+mj-lt" pitchFamily="34" charset="-120"/>
-              </a:rPr>
-              <a:t> → </a:t>
-            </a:r>
-            <a:pPr indent="0" marL="0">
-              <a:buNone/>
-            </a:pPr>
-            <a:r>
-              <a:rPr lang="en-US" sz="2400" b="1" dirty="0">
-                <a:solidFill>
-                  <a:schemeClr val="tx1"/>
-                </a:solidFill>
-                <a:highlight>
-                  <a:srgbClr val="FFFF00"/>
-                </a:highlight>
-                <a:latin typeface="+mj-lt" pitchFamily="34" charset="0"/>
-                <a:ea typeface="+mj-lt" pitchFamily="34" charset="-122"/>
-                <a:cs typeface="+mj-lt" pitchFamily="34" charset="-120"/>
-              </a:rPr>
-              <a:t>[₹ after]</a:t>
+              <a:t>₹15.6 L → ₹0</a:t>
             </a:r>
             <a:endParaRPr lang="en-US" sz="2400" dirty="0"/>
           </a:p>
@@ -3277,7 +3507,7 @@
                   <a:schemeClr val="accent2"/>
                 </a:solidFill>
               </a:rPr>
-              <a:t>Exposure at risk</a:t>
+              <a:t>7-day loss: wait vs fix today</a:t>
             </a:r>
             <a:endParaRPr lang="en-US" sz="1400" dirty="0"/>
           </a:p>
@@ -3387,7 +3617,7 @@
                   <a:schemeClr val="tx1"/>
                 </a:solidFill>
               </a:rPr>
-              <a:t>Real carrier integrations</a:t>
+              <a:t>Live carrier and ERP data</a:t>
             </a:r>
             <a:endParaRPr lang="en-US" sz="1800" dirty="0"/>
           </a:p>
@@ -3461,7 +3691,7 @@
                   <a:schemeClr val="tx1"/>
                 </a:solidFill>
               </a:rPr>
-              <a:t>Learned supplier reliability</a:t>
+              <a:t>Delay-prediction model</a:t>
             </a:r>
             <a:endParaRPr lang="en-US" sz="1800" dirty="0"/>
           </a:p>
@@ -3535,7 +3765,7 @@
                   <a:schemeClr val="tx1"/>
                 </a:solidFill>
               </a:rPr>
-              <a:t>Multi-warehouse optimisation</a:t>
+              <a:t>Spending limits, WhatsApp approvals</a:t>
             </a:r>
             <a:endParaRPr lang="en-US" sz="1800" dirty="0"/>
           </a:p>
@@ -4311,22 +4541,8 @@
                 <a:solidFill>
                   <a:schemeClr val="tx1"/>
                 </a:solidFill>
-                <a:highlight>
-                  <a:srgbClr val="FFFF00"/>
-                </a:highlight>
-              </a:rPr>
-              <a:t>[CONFIRM FINAL STACK]</a:t>
-            </a:r>
-            <a:pPr indent="0" marL="0">
-              <a:buNone/>
-            </a:pPr>
-            <a:r>
-              <a:rPr lang="en-US" sz="1200" dirty="0">
-                <a:solidFill>
-                  <a:schemeClr val="tx1"/>
-                </a:solidFill>
-              </a:rPr>
-              <a:t>  Planned: Next.js, TypeScript, Postgres on Neon, Prisma, Anthropic API, deployed on Vercel</a:t>
+              </a:rPr>
+              <a:t>Live demo: JavaScript page + Vercel serverless function + Google Gemini 3.5 Flash-Lite.  Full app: Next.js 15, React 19, TypeScript, Prisma, PostgreSQL.</a:t>
             </a:r>
             <a:endParaRPr lang="en-US" sz="1200" dirty="0"/>
           </a:p>
@@ -4361,36 +4577,8 @@
                 <a:solidFill>
                   <a:schemeClr val="tx1"/>
                 </a:solidFill>
-                <a:highlight>
-                  <a:srgbClr val="FFFF00"/>
-                </a:highlight>
-              </a:rPr>
-              <a:t>[LIVE DEMO URL]</a:t>
-            </a:r>
-            <a:pPr indent="0" marL="0">
-              <a:buNone/>
-            </a:pPr>
-            <a:r>
-              <a:rPr lang="en-US" sz="1100" dirty="0">
-                <a:solidFill>
-                  <a:schemeClr val="tx1"/>
-                </a:solidFill>
-              </a:rPr>
-              <a:t>     </a:t>
-            </a:r>
-            <a:pPr indent="0" marL="0">
-              <a:buNone/>
-            </a:pPr>
-            <a:r>
-              <a:rPr lang="en-US" sz="1100" dirty="0">
-                <a:solidFill>
-                  <a:schemeClr val="tx1"/>
-                </a:solidFill>
-                <a:highlight>
-                  <a:srgbClr val="FFFF00"/>
-                </a:highlight>
-              </a:rPr>
-              <a:t>[GITHUB REPO URL]</a:t>
+              </a:rPr>
+              <a:t>disruptioniq.vercel.app   ·   github.com/RakeshKumar-18/disruptionIQ</a:t>
             </a:r>
             <a:endParaRPr lang="en-US" sz="1100" dirty="0"/>
           </a:p>
@@ -4436,6 +4624,1290 @@
             <a:fld id="{F7021451-1387-4CA6-816F-3879F97B5CBC}" type="slidenum">
               <a:rPr b="0" lang="en-US"/>
               <a:t>11</a:t>
+            </a:fld>
+            <a:endParaRPr lang="en-US"/>
+          </a:p>
+        </p:txBody>
+      </p:sp>
+    </p:spTree>
+  </p:cSld>
+  <p:clrMapOvr>
+    <a:masterClrMapping/>
+  </p:clrMapOvr>
+</p:sld>
+</file>
+
+<file path=ppt/slides/slide12.xml><?xml version="1.0" encoding="utf-8"?>
+<p:sld xmlns:a="http://schemas.openxmlformats.org/drawingml/2006/main" xmlns:r="http://schemas.openxmlformats.org/officeDocument/2006/relationships" xmlns:p="http://schemas.openxmlformats.org/presentationml/2006/main">
+  <p:cSld name="Slide 6">
+    <p:spTree>
+      <p:nvGrpSpPr>
+        <p:cNvPr id="1" name=""/>
+        <p:cNvGrpSpPr/>
+        <p:nvPr/>
+      </p:nvGrpSpPr>
+      <p:grpSpPr>
+        <a:xfrm>
+          <a:off x="0" y="0"/>
+          <a:ext cx="0" cy="0"/>
+          <a:chOff x="0" y="0"/>
+          <a:chExt cx="0" cy="0"/>
+        </a:xfrm>
+      </p:grpSpPr>
+      <p:sp>
+        <p:nvSpPr>
+          <p:cNvPr id="2" name="Text 3"/>
+          <p:cNvSpPr/>
+          <p:nvPr>
+            <p:ph idx="105" type="body" hasCustomPrompt="1"/>
+          </p:nvPr>
+        </p:nvSpPr>
+        <p:spPr>
+          <a:xfrm>
+            <a:off x="457200" y="822960"/>
+            <a:ext cx="8229600" cy="256032"/>
+          </a:xfrm>
+          <a:prstGeom prst="rect">
+            <a:avLst/>
+          </a:prstGeom>
+          <a:noFill/>
+          <a:ln/>
+        </p:spPr>
+        <p:txBody>
+          <a:bodyPr wrap="square" lIns="0" tIns="0" rIns="0" bIns="0" rtlCol="0" anchor="t"/>
+          <a:lstStyle/>
+          <a:p>
+            <a:pPr algn="l" indent="0" marL="0">
+              <a:buNone/>
+            </a:pPr>
+            <a:r>
+              <a:rPr lang="en-US" sz="1200" b="1" dirty="0">
+                <a:solidFill>
+                  <a:schemeClr val="accent1"/>
+                </a:solidFill>
+              </a:rPr>
+              <a:t>Technical Approach</a:t>
+            </a:r>
+            <a:pPr algn="l" indent="0" marL="0">
+              <a:buNone/>
+            </a:pPr>
+            <a:r>
+              <a:rPr lang="en-US" sz="1200" b="1" dirty="0">
+                <a:solidFill>
+                  <a:schemeClr val="accent2"/>
+                </a:solidFill>
+              </a:rPr>
+              <a:t>  ·  Stress test</a:t>
+            </a:r>
+            <a:endParaRPr lang="en-US" sz="1200" dirty="0"/>
+          </a:p>
+        </p:txBody>
+      </p:sp>
+      <p:sp>
+        <p:nvSpPr>
+          <p:cNvPr id="3" name="Text 3"/>
+          <p:cNvSpPr/>
+          <p:nvPr>
+            <p:ph idx="106" type="title" hasCustomPrompt="1"/>
+          </p:nvPr>
+        </p:nvSpPr>
+        <p:spPr>
+          <a:xfrm>
+            <a:off x="457200" y="1069848"/>
+            <a:ext cx="8229600" cy="841248"/>
+          </a:xfrm>
+          <a:prstGeom prst="rect">
+            <a:avLst/>
+          </a:prstGeom>
+          <a:noFill/>
+          <a:ln/>
+        </p:spPr>
+        <p:txBody>
+          <a:bodyPr wrap="square" lIns="0" tIns="0" rIns="0" bIns="0" rtlCol="0" anchor="t"/>
+          <a:lstStyle/>
+          <a:p>
+            <a:pPr algn="l" indent="0" marL="0">
+              <a:buNone/>
+            </a:pPr>
+            <a:r>
+              <a:rPr lang="en-US" sz="2600" b="1" dirty="0">
+                <a:solidFill>
+                  <a:schemeClr val="tx1"/>
+                </a:solidFill>
+              </a:rPr>
+              <a:t>Break the network on purpose, before it breaks for real.</a:t>
+            </a:r>
+            <a:endParaRPr lang="en-US" sz="2600" dirty="0"/>
+          </a:p>
+        </p:txBody>
+      </p:sp>
+      <p:sp>
+        <p:nvSpPr>
+          <p:cNvPr id="6" name="Text 4"/>
+          <p:cNvSpPr txBox="1"/>
+          <p:nvPr/>
+        </p:nvSpPr>
+        <p:spPr>
+          <a:xfrm>
+            <a:off x="6080760" y="2103120"/>
+            <a:ext cx="2606040" cy="320040"/>
+          </a:xfrm>
+          <a:prstGeom prst="rect">
+            <a:avLst/>
+          </a:prstGeom>
+          <a:noFill/>
+          <a:ln/>
+        </p:spPr>
+        <p:txBody>
+          <a:bodyPr wrap="square" lIns="0" tIns="0" rIns="0" bIns="0" rtlCol="0" anchor="t"/>
+          <a:lstStyle/>
+          <a:p>
+            <a:pPr indent="0" marL="0">
+              <a:buNone/>
+            </a:pPr>
+            <a:r>
+              <a:rPr lang="en-US" sz="1500" b="1" dirty="0">
+                <a:solidFill>
+                  <a:schemeClr val="accent2"/>
+                </a:solidFill>
+              </a:rPr>
+              <a:t>Fail each site for 7 days</a:t>
+            </a:r>
+            <a:endParaRPr lang="en-US" sz="1500" dirty="0"/>
+          </a:p>
+        </p:txBody>
+      </p:sp>
+      <p:sp>
+        <p:nvSpPr>
+          <p:cNvPr id="7" name="Shape 5"/>
+          <p:cNvSpPr/>
+          <p:nvPr/>
+        </p:nvSpPr>
+        <p:spPr>
+          <a:xfrm>
+            <a:off x="6080760" y="2706624"/>
+            <a:ext cx="109728" cy="109728"/>
+          </a:xfrm>
+          <a:prstGeom prst="ellipse">
+            <a:avLst/>
+          </a:prstGeom>
+          <a:solidFill>
+            <a:schemeClr val="accent1"/>
+          </a:solidFill>
+          <a:ln/>
+        </p:spPr>
+      </p:sp>
+      <p:sp>
+        <p:nvSpPr>
+          <p:cNvPr id="8" name="Text 6"/>
+          <p:cNvSpPr txBox="1"/>
+          <p:nvPr/>
+        </p:nvSpPr>
+        <p:spPr>
+          <a:xfrm>
+            <a:off x="6327648" y="2606040"/>
+            <a:ext cx="2377440" cy="310896"/>
+          </a:xfrm>
+          <a:prstGeom prst="rect">
+            <a:avLst/>
+          </a:prstGeom>
+          <a:noFill/>
+          <a:ln/>
+        </p:spPr>
+        <p:txBody>
+          <a:bodyPr wrap="square" lIns="0" tIns="0" rIns="0" bIns="0" rtlCol="0" anchor="ctr"/>
+          <a:lstStyle/>
+          <a:p>
+            <a:pPr indent="0" marL="0">
+              <a:buNone/>
+            </a:pPr>
+            <a:r>
+              <a:rPr lang="en-US" sz="1700" dirty="0">
+                <a:solidFill>
+                  <a:schemeClr val="tx1"/>
+                </a:solidFill>
+              </a:rPr>
+              <a:t>₹ and orders hit</a:t>
+            </a:r>
+            <a:endParaRPr lang="en-US" sz="1700" dirty="0"/>
+          </a:p>
+        </p:txBody>
+      </p:sp>
+      <p:sp>
+        <p:nvSpPr>
+          <p:cNvPr id="9" name="Shape 7"/>
+          <p:cNvSpPr/>
+          <p:nvPr/>
+        </p:nvSpPr>
+        <p:spPr>
+          <a:xfrm>
+            <a:off x="6080760" y="3099816"/>
+            <a:ext cx="109728" cy="109728"/>
+          </a:xfrm>
+          <a:prstGeom prst="ellipse">
+            <a:avLst/>
+          </a:prstGeom>
+          <a:solidFill>
+            <a:schemeClr val="accent1"/>
+          </a:solidFill>
+          <a:ln/>
+        </p:spPr>
+      </p:sp>
+      <p:sp>
+        <p:nvSpPr>
+          <p:cNvPr id="10" name="Text 8"/>
+          <p:cNvSpPr txBox="1"/>
+          <p:nvPr/>
+        </p:nvSpPr>
+        <p:spPr>
+          <a:xfrm>
+            <a:off x="6327648" y="2999232"/>
+            <a:ext cx="2377440" cy="310896"/>
+          </a:xfrm>
+          <a:prstGeom prst="rect">
+            <a:avLst/>
+          </a:prstGeom>
+          <a:noFill/>
+          <a:ln/>
+        </p:spPr>
+        <p:txBody>
+          <a:bodyPr wrap="square" lIns="0" tIns="0" rIns="0" bIns="0" rtlCol="0" anchor="ctr"/>
+          <a:lstStyle/>
+          <a:p>
+            <a:pPr indent="0" marL="0">
+              <a:buNone/>
+            </a:pPr>
+            <a:r>
+              <a:rPr lang="en-US" sz="1700" dirty="0">
+                <a:solidFill>
+                  <a:schemeClr val="tx1"/>
+                </a:solidFill>
+              </a:rPr>
+              <a:t>Orders with no backup</a:t>
+            </a:r>
+            <a:endParaRPr lang="en-US" sz="1700" dirty="0"/>
+          </a:p>
+        </p:txBody>
+      </p:sp>
+      <p:sp>
+        <p:nvSpPr>
+          <p:cNvPr id="11" name="Shape 9"/>
+          <p:cNvSpPr/>
+          <p:nvPr/>
+        </p:nvSpPr>
+        <p:spPr>
+          <a:xfrm>
+            <a:off x="6080760" y="3493008"/>
+            <a:ext cx="109728" cy="109728"/>
+          </a:xfrm>
+          <a:prstGeom prst="ellipse">
+            <a:avLst/>
+          </a:prstGeom>
+          <a:solidFill>
+            <a:schemeClr val="accent1"/>
+          </a:solidFill>
+          <a:ln/>
+        </p:spPr>
+      </p:sp>
+      <p:sp>
+        <p:nvSpPr>
+          <p:cNvPr id="12" name="Text 10"/>
+          <p:cNvSpPr txBox="1"/>
+          <p:nvPr/>
+        </p:nvSpPr>
+        <p:spPr>
+          <a:xfrm>
+            <a:off x="6327648" y="3392424"/>
+            <a:ext cx="2377440" cy="310896"/>
+          </a:xfrm>
+          <a:prstGeom prst="rect">
+            <a:avLst/>
+          </a:prstGeom>
+          <a:noFill/>
+          <a:ln/>
+        </p:spPr>
+        <p:txBody>
+          <a:bodyPr wrap="square" lIns="0" tIns="0" rIns="0" bIns="0" rtlCol="0" anchor="ctr"/>
+          <a:lstStyle/>
+          <a:p>
+            <a:pPr indent="0" marL="0">
+              <a:buNone/>
+            </a:pPr>
+            <a:r>
+              <a:rPr lang="en-US" sz="1700" dirty="0">
+                <a:solidFill>
+                  <a:schemeClr val="tx1"/>
+                </a:solidFill>
+              </a:rPr>
+              <a:t>Top 3 weak spots</a:t>
+            </a:r>
+            <a:endParaRPr lang="en-US" sz="1700" dirty="0"/>
+          </a:p>
+        </p:txBody>
+      </p:sp>
+      <p:sp>
+        <p:nvSpPr>
+          <p:cNvPr id="13" name="Shape 11"/>
+          <p:cNvSpPr/>
+          <p:nvPr/>
+        </p:nvSpPr>
+        <p:spPr>
+          <a:xfrm>
+            <a:off x="6080760" y="3886200"/>
+            <a:ext cx="109728" cy="109728"/>
+          </a:xfrm>
+          <a:prstGeom prst="ellipse">
+            <a:avLst/>
+          </a:prstGeom>
+          <a:solidFill>
+            <a:schemeClr val="accent1"/>
+          </a:solidFill>
+          <a:ln/>
+        </p:spPr>
+      </p:sp>
+      <p:sp>
+        <p:nvSpPr>
+          <p:cNvPr id="14" name="Text 12"/>
+          <p:cNvSpPr txBox="1"/>
+          <p:nvPr/>
+        </p:nvSpPr>
+        <p:spPr>
+          <a:xfrm>
+            <a:off x="6327648" y="3785616"/>
+            <a:ext cx="2377440" cy="310896"/>
+          </a:xfrm>
+          <a:prstGeom prst="rect">
+            <a:avLst/>
+          </a:prstGeom>
+          <a:noFill/>
+          <a:ln/>
+        </p:spPr>
+        <p:txBody>
+          <a:bodyPr wrap="square" lIns="0" tIns="0" rIns="0" bIns="0" rtlCol="0" anchor="ctr"/>
+          <a:lstStyle/>
+          <a:p>
+            <a:pPr indent="0" marL="0">
+              <a:buNone/>
+            </a:pPr>
+            <a:r>
+              <a:rPr lang="en-US" sz="1700" dirty="0">
+                <a:solidFill>
+                  <a:schemeClr val="tx1"/>
+                </a:solidFill>
+              </a:rPr>
+              <a:t>A fix for each one</a:t>
+            </a:r>
+            <a:endParaRPr lang="en-US" sz="1700" dirty="0"/>
+          </a:p>
+        </p:txBody>
+      </p:sp>
+      <p:sp>
+        <p:nvSpPr>
+          <p:cNvPr id="15" name="Shape 13"/>
+          <p:cNvSpPr/>
+          <p:nvPr/>
+        </p:nvSpPr>
+        <p:spPr>
+          <a:xfrm>
+            <a:off x="6080760" y="4279392"/>
+            <a:ext cx="109728" cy="109728"/>
+          </a:xfrm>
+          <a:prstGeom prst="ellipse">
+            <a:avLst/>
+          </a:prstGeom>
+          <a:solidFill>
+            <a:schemeClr val="accent1"/>
+          </a:solidFill>
+          <a:ln/>
+        </p:spPr>
+      </p:sp>
+      <p:sp>
+        <p:nvSpPr>
+          <p:cNvPr id="16" name="Text 14"/>
+          <p:cNvSpPr txBox="1"/>
+          <p:nvPr/>
+        </p:nvSpPr>
+        <p:spPr>
+          <a:xfrm>
+            <a:off x="6327648" y="4178808"/>
+            <a:ext cx="2377440" cy="310896"/>
+          </a:xfrm>
+          <a:prstGeom prst="rect">
+            <a:avLst/>
+          </a:prstGeom>
+          <a:noFill/>
+          <a:ln/>
+        </p:spPr>
+        <p:txBody>
+          <a:bodyPr wrap="square" lIns="0" tIns="0" rIns="0" bIns="0" rtlCol="0" anchor="ctr"/>
+          <a:lstStyle/>
+          <a:p>
+            <a:pPr indent="0" marL="0">
+              <a:buNone/>
+            </a:pPr>
+            <a:r>
+              <a:rPr lang="en-US" sz="1700" dirty="0">
+                <a:solidFill>
+                  <a:schemeClr val="tx1"/>
+                </a:solidFill>
+              </a:rPr>
+              <a:t>Gemini explains it</a:t>
+            </a:r>
+            <a:endParaRPr lang="en-US" sz="1700" dirty="0"/>
+          </a:p>
+        </p:txBody>
+      </p:sp>
+      <p:pic>
+        <p:nvPicPr>
+          <p:cNvPr id="63" name="Screenshot 3" descr="Stress test map: fragility heat map, the three most fragile points and an AI explanation"/>
+          <p:cNvPicPr>
+            <a:picLocks noChangeAspect="1"/>
+          </p:cNvPicPr>
+          <p:nvPr/>
+        </p:nvPicPr>
+        <p:blipFill>
+          <a:blip r:embed="rId2"/>
+          <a:stretch>
+            <a:fillRect/>
+          </a:stretch>
+        </p:blipFill>
+        <p:spPr>
+          <a:xfrm>
+            <a:off x="457200" y="2057400"/>
+            <a:ext cx="3394071" cy="2468880"/>
+          </a:xfrm>
+          <a:prstGeom prst="rect">
+            <a:avLst/>
+          </a:prstGeom>
+          <a:ln w="9525">
+            <a:solidFill>
+              <a:srgbClr val="BFBFBF"/>
+            </a:solidFill>
+          </a:ln>
+        </p:spPr>
+      </p:pic>
+      <p:sp>
+        <p:nvSpPr>
+          <p:cNvPr id="25" name="Slide Number Placeholder 0"/>
+          <p:cNvSpPr>
+            <a:spLocks noGrp="1"/>
+          </p:cNvSpPr>
+          <p:nvPr>
+            <p:ph type="sldNum" sz="quarter" idx="4294967295"/>
+          </p:nvPr>
+        </p:nvSpPr>
+        <p:spPr>
+          <a:xfrm>
+            <a:off x="8229600" y="4754880"/>
+            <a:ext cx="457200" cy="228600"/>
+          </a:xfrm>
+          <a:prstGeom prst="rect">
+            <a:avLst/>
+          </a:prstGeom>
+          <a:extLst>
+            <a:ext uri="{C572A759-6A51-4108-AA02-DFA0A04FC94B}">
+              <ma14:wrappingTextBoxFlag xmlns:ma14="http://schemas.microsoft.com/office/mac/drawingml/2011/main" val="0"/>
+            </a:ext>
+          </a:extLst>
+        </p:spPr>
+        <p:txBody>
+          <a:bodyPr lIns="0" tIns="0" rIns="0" bIns="0" anchor="ctr"/>
+          <a:lstStyle>
+            <a:lvl1pPr>
+              <a:defRPr sz="1000">
+                <a:solidFill>
+                  <a:schemeClr val="accent2"/>
+                </a:solidFill>
+              </a:defRPr>
+            </a:lvl1pPr>
+          </a:lstStyle>
+          <a:p>
+            <a:pPr algn="r"/>
+            <a:fld id="{F7021451-1387-4CA6-816F-3879F97B5CBC}" type="slidenum">
+              <a:rPr b="0" lang="en-US"/>
+              <a:t>6</a:t>
+            </a:fld>
+            <a:endParaRPr lang="en-US"/>
+          </a:p>
+        </p:txBody>
+      </p:sp>
+    </p:spTree>
+  </p:cSld>
+  <p:clrMapOvr>
+    <a:masterClrMapping/>
+  </p:clrMapOvr>
+</p:sld>
+</file>
+
+<file path=ppt/slides/slide13.xml><?xml version="1.0" encoding="utf-8"?>
+<p:sld xmlns:a="http://schemas.openxmlformats.org/drawingml/2006/main" xmlns:r="http://schemas.openxmlformats.org/officeDocument/2006/relationships" xmlns:p="http://schemas.openxmlformats.org/presentationml/2006/main">
+  <p:cSld name="Slide 6">
+    <p:spTree>
+      <p:nvGrpSpPr>
+        <p:cNvPr id="1" name=""/>
+        <p:cNvGrpSpPr/>
+        <p:nvPr/>
+      </p:nvGrpSpPr>
+      <p:grpSpPr>
+        <a:xfrm>
+          <a:off x="0" y="0"/>
+          <a:ext cx="0" cy="0"/>
+          <a:chOff x="0" y="0"/>
+          <a:chExt cx="0" cy="0"/>
+        </a:xfrm>
+      </p:grpSpPr>
+      <p:sp>
+        <p:nvSpPr>
+          <p:cNvPr id="2" name="Text 3"/>
+          <p:cNvSpPr/>
+          <p:nvPr>
+            <p:ph idx="105" type="body" hasCustomPrompt="1"/>
+          </p:nvPr>
+        </p:nvSpPr>
+        <p:spPr>
+          <a:xfrm>
+            <a:off x="457200" y="822960"/>
+            <a:ext cx="8229600" cy="256032"/>
+          </a:xfrm>
+          <a:prstGeom prst="rect">
+            <a:avLst/>
+          </a:prstGeom>
+          <a:noFill/>
+          <a:ln/>
+        </p:spPr>
+        <p:txBody>
+          <a:bodyPr wrap="square" lIns="0" tIns="0" rIns="0" bIns="0" rtlCol="0" anchor="t"/>
+          <a:lstStyle/>
+          <a:p>
+            <a:pPr algn="l" indent="0" marL="0">
+              <a:buNone/>
+            </a:pPr>
+            <a:r>
+              <a:rPr lang="en-US" sz="1200" b="1" dirty="0">
+                <a:solidFill>
+                  <a:schemeClr val="accent1"/>
+                </a:solidFill>
+              </a:rPr>
+              <a:t>Technical Approach</a:t>
+            </a:r>
+            <a:pPr algn="l" indent="0" marL="0">
+              <a:buNone/>
+            </a:pPr>
+            <a:r>
+              <a:rPr lang="en-US" sz="1200" b="1" dirty="0">
+                <a:solidFill>
+                  <a:schemeClr val="accent2"/>
+                </a:solidFill>
+              </a:rPr>
+              <a:t>  ·  Ripple replay</a:t>
+            </a:r>
+            <a:endParaRPr lang="en-US" sz="1200" dirty="0"/>
+          </a:p>
+        </p:txBody>
+      </p:sp>
+      <p:sp>
+        <p:nvSpPr>
+          <p:cNvPr id="3" name="Text 3"/>
+          <p:cNvSpPr/>
+          <p:nvPr>
+            <p:ph idx="106" type="title" hasCustomPrompt="1"/>
+          </p:nvPr>
+        </p:nvSpPr>
+        <p:spPr>
+          <a:xfrm>
+            <a:off x="457200" y="1069848"/>
+            <a:ext cx="8229600" cy="841248"/>
+          </a:xfrm>
+          <a:prstGeom prst="rect">
+            <a:avLst/>
+          </a:prstGeom>
+          <a:noFill/>
+          <a:ln/>
+        </p:spPr>
+        <p:txBody>
+          <a:bodyPr wrap="square" lIns="0" tIns="0" rIns="0" bIns="0" rtlCol="0" anchor="t"/>
+          <a:lstStyle/>
+          <a:p>
+            <a:pPr algn="l" indent="0" marL="0">
+              <a:buNone/>
+            </a:pPr>
+            <a:r>
+              <a:rPr lang="en-US" sz="2600" b="1" dirty="0">
+                <a:solidFill>
+                  <a:schemeClr val="tx1"/>
+                </a:solidFill>
+              </a:rPr>
+              <a:t>Every day of waiting has a price.</a:t>
+            </a:r>
+            <a:endParaRPr lang="en-US" sz="2600" dirty="0"/>
+          </a:p>
+        </p:txBody>
+      </p:sp>
+      <p:sp>
+        <p:nvSpPr>
+          <p:cNvPr id="6" name="Text 4"/>
+          <p:cNvSpPr txBox="1"/>
+          <p:nvPr/>
+        </p:nvSpPr>
+        <p:spPr>
+          <a:xfrm>
+            <a:off x="6080760" y="2103120"/>
+            <a:ext cx="2606040" cy="320040"/>
+          </a:xfrm>
+          <a:prstGeom prst="rect">
+            <a:avLst/>
+          </a:prstGeom>
+          <a:noFill/>
+          <a:ln/>
+        </p:spPr>
+        <p:txBody>
+          <a:bodyPr wrap="square" lIns="0" tIns="0" rIns="0" bIns="0" rtlCol="0" anchor="t"/>
+          <a:lstStyle/>
+          <a:p>
+            <a:pPr indent="0" marL="0">
+              <a:buNone/>
+            </a:pPr>
+            <a:r>
+              <a:rPr lang="en-US" sz="1500" b="1" dirty="0">
+                <a:solidFill>
+                  <a:schemeClr val="accent2"/>
+                </a:solidFill>
+              </a:rPr>
+              <a:t>Next 7 days, two futures</a:t>
+            </a:r>
+            <a:endParaRPr lang="en-US" sz="1500" dirty="0"/>
+          </a:p>
+        </p:txBody>
+      </p:sp>
+      <p:sp>
+        <p:nvSpPr>
+          <p:cNvPr id="7" name="Shape 5"/>
+          <p:cNvSpPr/>
+          <p:nvPr/>
+        </p:nvSpPr>
+        <p:spPr>
+          <a:xfrm>
+            <a:off x="6080760" y="2706624"/>
+            <a:ext cx="109728" cy="109728"/>
+          </a:xfrm>
+          <a:prstGeom prst="ellipse">
+            <a:avLst/>
+          </a:prstGeom>
+          <a:solidFill>
+            <a:schemeClr val="accent1"/>
+          </a:solidFill>
+          <a:ln/>
+        </p:spPr>
+      </p:sp>
+      <p:sp>
+        <p:nvSpPr>
+          <p:cNvPr id="8" name="Text 6"/>
+          <p:cNvSpPr txBox="1"/>
+          <p:nvPr/>
+        </p:nvSpPr>
+        <p:spPr>
+          <a:xfrm>
+            <a:off x="6327648" y="2606040"/>
+            <a:ext cx="2377440" cy="310896"/>
+          </a:xfrm>
+          <a:prstGeom prst="rect">
+            <a:avLst/>
+          </a:prstGeom>
+          <a:noFill/>
+          <a:ln/>
+        </p:spPr>
+        <p:txBody>
+          <a:bodyPr wrap="square" lIns="0" tIns="0" rIns="0" bIns="0" rtlCol="0" anchor="ctr"/>
+          <a:lstStyle/>
+          <a:p>
+            <a:pPr indent="0" marL="0">
+              <a:buNone/>
+            </a:pPr>
+            <a:r>
+              <a:rPr lang="en-US" sz="1700" dirty="0">
+                <a:solidFill>
+                  <a:schemeClr val="tx1"/>
+                </a:solidFill>
+              </a:rPr>
+              <a:t>Wait: ₹15.6 L lost</a:t>
+            </a:r>
+            <a:endParaRPr lang="en-US" sz="1700" dirty="0"/>
+          </a:p>
+        </p:txBody>
+      </p:sp>
+      <p:sp>
+        <p:nvSpPr>
+          <p:cNvPr id="9" name="Shape 7"/>
+          <p:cNvSpPr/>
+          <p:nvPr/>
+        </p:nvSpPr>
+        <p:spPr>
+          <a:xfrm>
+            <a:off x="6080760" y="3099816"/>
+            <a:ext cx="109728" cy="109728"/>
+          </a:xfrm>
+          <a:prstGeom prst="ellipse">
+            <a:avLst/>
+          </a:prstGeom>
+          <a:solidFill>
+            <a:schemeClr val="accent1"/>
+          </a:solidFill>
+          <a:ln/>
+        </p:spPr>
+      </p:sp>
+      <p:sp>
+        <p:nvSpPr>
+          <p:cNvPr id="10" name="Text 8"/>
+          <p:cNvSpPr txBox="1"/>
+          <p:nvPr/>
+        </p:nvSpPr>
+        <p:spPr>
+          <a:xfrm>
+            <a:off x="6327648" y="2999232"/>
+            <a:ext cx="2377440" cy="310896"/>
+          </a:xfrm>
+          <a:prstGeom prst="rect">
+            <a:avLst/>
+          </a:prstGeom>
+          <a:noFill/>
+          <a:ln/>
+        </p:spPr>
+        <p:txBody>
+          <a:bodyPr wrap="square" lIns="0" tIns="0" rIns="0" bIns="0" rtlCol="0" anchor="ctr"/>
+          <a:lstStyle/>
+          <a:p>
+            <a:pPr indent="0" marL="0">
+              <a:buNone/>
+            </a:pPr>
+            <a:r>
+              <a:rPr lang="en-US" sz="1700" dirty="0">
+                <a:solidFill>
+                  <a:schemeClr val="tx1"/>
+                </a:solidFill>
+              </a:rPr>
+              <a:t>Fix today: ₹0 lost</a:t>
+            </a:r>
+            <a:endParaRPr lang="en-US" sz="1700" dirty="0"/>
+          </a:p>
+        </p:txBody>
+      </p:sp>
+      <p:sp>
+        <p:nvSpPr>
+          <p:cNvPr id="11" name="Shape 9"/>
+          <p:cNvSpPr/>
+          <p:nvPr/>
+        </p:nvSpPr>
+        <p:spPr>
+          <a:xfrm>
+            <a:off x="6080760" y="3493008"/>
+            <a:ext cx="109728" cy="109728"/>
+          </a:xfrm>
+          <a:prstGeom prst="ellipse">
+            <a:avLst/>
+          </a:prstGeom>
+          <a:solidFill>
+            <a:schemeClr val="accent1"/>
+          </a:solidFill>
+          <a:ln/>
+        </p:spPr>
+      </p:sp>
+      <p:sp>
+        <p:nvSpPr>
+          <p:cNvPr id="12" name="Text 10"/>
+          <p:cNvSpPr txBox="1"/>
+          <p:nvPr/>
+        </p:nvSpPr>
+        <p:spPr>
+          <a:xfrm>
+            <a:off x="6327648" y="3392424"/>
+            <a:ext cx="2377440" cy="310896"/>
+          </a:xfrm>
+          <a:prstGeom prst="rect">
+            <a:avLst/>
+          </a:prstGeom>
+          <a:noFill/>
+          <a:ln/>
+        </p:spPr>
+        <p:txBody>
+          <a:bodyPr wrap="square" lIns="0" tIns="0" rIns="0" bIns="0" rtlCol="0" anchor="ctr"/>
+          <a:lstStyle/>
+          <a:p>
+            <a:pPr indent="0" marL="0">
+              <a:buNone/>
+            </a:pPr>
+            <a:r>
+              <a:rPr lang="en-US" sz="1700" dirty="0">
+                <a:solidFill>
+                  <a:schemeClr val="tx1"/>
+                </a:solidFill>
+              </a:rPr>
+              <a:t>Missed orders turn red</a:t>
+            </a:r>
+            <a:endParaRPr lang="en-US" sz="1700" dirty="0"/>
+          </a:p>
+        </p:txBody>
+      </p:sp>
+      <p:sp>
+        <p:nvSpPr>
+          <p:cNvPr id="13" name="Shape 11"/>
+          <p:cNvSpPr/>
+          <p:nvPr/>
+        </p:nvSpPr>
+        <p:spPr>
+          <a:xfrm>
+            <a:off x="6080760" y="3886200"/>
+            <a:ext cx="109728" cy="109728"/>
+          </a:xfrm>
+          <a:prstGeom prst="ellipse">
+            <a:avLst/>
+          </a:prstGeom>
+          <a:solidFill>
+            <a:schemeClr val="accent1"/>
+          </a:solidFill>
+          <a:ln/>
+        </p:spPr>
+      </p:sp>
+      <p:sp>
+        <p:nvSpPr>
+          <p:cNvPr id="14" name="Text 12"/>
+          <p:cNvSpPr txBox="1"/>
+          <p:nvPr/>
+        </p:nvSpPr>
+        <p:spPr>
+          <a:xfrm>
+            <a:off x="6327648" y="3785616"/>
+            <a:ext cx="2377440" cy="310896"/>
+          </a:xfrm>
+          <a:prstGeom prst="rect">
+            <a:avLst/>
+          </a:prstGeom>
+          <a:noFill/>
+          <a:ln/>
+        </p:spPr>
+        <p:txBody>
+          <a:bodyPr wrap="square" lIns="0" tIns="0" rIns="0" bIns="0" rtlCol="0" anchor="ctr"/>
+          <a:lstStyle/>
+          <a:p>
+            <a:pPr indent="0" marL="0">
+              <a:buNone/>
+            </a:pPr>
+            <a:r>
+              <a:rPr lang="en-US" sz="1700" dirty="0">
+                <a:solidFill>
+                  <a:schemeClr val="tx1"/>
+                </a:solidFill>
+              </a:rPr>
+              <a:t>Fixes expire over time</a:t>
+            </a:r>
+            <a:endParaRPr lang="en-US" sz="1700" dirty="0"/>
+          </a:p>
+        </p:txBody>
+      </p:sp>
+      <p:sp>
+        <p:nvSpPr>
+          <p:cNvPr id="15" name="Shape 13"/>
+          <p:cNvSpPr/>
+          <p:nvPr/>
+        </p:nvSpPr>
+        <p:spPr>
+          <a:xfrm>
+            <a:off x="6080760" y="4279392"/>
+            <a:ext cx="109728" cy="109728"/>
+          </a:xfrm>
+          <a:prstGeom prst="ellipse">
+            <a:avLst/>
+          </a:prstGeom>
+          <a:solidFill>
+            <a:schemeClr val="accent1"/>
+          </a:solidFill>
+          <a:ln/>
+        </p:spPr>
+      </p:sp>
+      <p:sp>
+        <p:nvSpPr>
+          <p:cNvPr id="16" name="Text 14"/>
+          <p:cNvSpPr txBox="1"/>
+          <p:nvPr/>
+        </p:nvSpPr>
+        <p:spPr>
+          <a:xfrm>
+            <a:off x="6327648" y="4178808"/>
+            <a:ext cx="2377440" cy="310896"/>
+          </a:xfrm>
+          <a:prstGeom prst="rect">
+            <a:avLst/>
+          </a:prstGeom>
+          <a:noFill/>
+          <a:ln/>
+        </p:spPr>
+        <p:txBody>
+          <a:bodyPr wrap="square" lIns="0" tIns="0" rIns="0" bIns="0" rtlCol="0" anchor="ctr"/>
+          <a:lstStyle/>
+          <a:p>
+            <a:pPr indent="0" marL="0">
+              <a:buNone/>
+            </a:pPr>
+            <a:r>
+              <a:rPr lang="en-US" sz="1700" dirty="0">
+                <a:solidFill>
+                  <a:schemeClr val="tx1"/>
+                </a:solidFill>
+              </a:rPr>
+              <a:t>Press play in the demo</a:t>
+            </a:r>
+            <a:endParaRPr lang="en-US" sz="1700" dirty="0"/>
+          </a:p>
+        </p:txBody>
+      </p:sp>
+      <p:pic>
+        <p:nvPicPr>
+          <p:cNvPr id="64" name="Screenshot 4" descr="Ripple replay at day 5: orders missed and value lost if nobody acts, with a chart against fixing today"/>
+          <p:cNvPicPr>
+            <a:picLocks noChangeAspect="1"/>
+          </p:cNvPicPr>
+          <p:nvPr/>
+        </p:nvPicPr>
+        <p:blipFill>
+          <a:blip r:embed="rId2"/>
+          <a:stretch>
+            <a:fillRect/>
+          </a:stretch>
+        </p:blipFill>
+        <p:spPr>
+          <a:xfrm>
+            <a:off x="457200" y="2139868"/>
+            <a:ext cx="5257800" cy="2303943"/>
+          </a:xfrm>
+          <a:prstGeom prst="rect">
+            <a:avLst/>
+          </a:prstGeom>
+          <a:ln w="9525">
+            <a:solidFill>
+              <a:srgbClr val="BFBFBF"/>
+            </a:solidFill>
+          </a:ln>
+        </p:spPr>
+      </p:pic>
+      <p:sp>
+        <p:nvSpPr>
+          <p:cNvPr id="25" name="Slide Number Placeholder 0"/>
+          <p:cNvSpPr>
+            <a:spLocks noGrp="1"/>
+          </p:cNvSpPr>
+          <p:nvPr>
+            <p:ph type="sldNum" sz="quarter" idx="4294967295"/>
+          </p:nvPr>
+        </p:nvSpPr>
+        <p:spPr>
+          <a:xfrm>
+            <a:off x="8229600" y="4754880"/>
+            <a:ext cx="457200" cy="228600"/>
+          </a:xfrm>
+          <a:prstGeom prst="rect">
+            <a:avLst/>
+          </a:prstGeom>
+          <a:extLst>
+            <a:ext uri="{C572A759-6A51-4108-AA02-DFA0A04FC94B}">
+              <ma14:wrappingTextBoxFlag xmlns:ma14="http://schemas.microsoft.com/office/mac/drawingml/2011/main" val="0"/>
+            </a:ext>
+          </a:extLst>
+        </p:spPr>
+        <p:txBody>
+          <a:bodyPr lIns="0" tIns="0" rIns="0" bIns="0" anchor="ctr"/>
+          <a:lstStyle>
+            <a:lvl1pPr>
+              <a:defRPr sz="1000">
+                <a:solidFill>
+                  <a:schemeClr val="accent2"/>
+                </a:solidFill>
+              </a:defRPr>
+            </a:lvl1pPr>
+          </a:lstStyle>
+          <a:p>
+            <a:pPr algn="r"/>
+            <a:fld id="{F7021451-1387-4CA6-816F-3879F97B5CBC}" type="slidenum">
+              <a:rPr b="0" lang="en-US"/>
+              <a:t>6</a:t>
+            </a:fld>
+            <a:endParaRPr lang="en-US"/>
+          </a:p>
+        </p:txBody>
+      </p:sp>
+    </p:spTree>
+  </p:cSld>
+  <p:clrMapOvr>
+    <a:masterClrMapping/>
+  </p:clrMapOvr>
+</p:sld>
+</file>
+
+<file path=ppt/slides/slide14.xml><?xml version="1.0" encoding="utf-8"?>
+<p:sld xmlns:a="http://schemas.openxmlformats.org/drawingml/2006/main" xmlns:r="http://schemas.openxmlformats.org/officeDocument/2006/relationships" xmlns:p="http://schemas.openxmlformats.org/presentationml/2006/main">
+  <p:cSld name="Slide 7">
+    <p:spTree>
+      <p:nvGrpSpPr>
+        <p:cNvPr id="1" name=""/>
+        <p:cNvGrpSpPr/>
+        <p:nvPr/>
+      </p:nvGrpSpPr>
+      <p:grpSpPr>
+        <a:xfrm>
+          <a:off x="0" y="0"/>
+          <a:ext cx="0" cy="0"/>
+          <a:chOff x="0" y="0"/>
+          <a:chExt cx="0" cy="0"/>
+        </a:xfrm>
+      </p:grpSpPr>
+      <p:sp>
+        <p:nvSpPr>
+          <p:cNvPr id="2" name="Text 3"/>
+          <p:cNvSpPr/>
+          <p:nvPr>
+            <p:ph idx="105" type="body" hasCustomPrompt="1"/>
+          </p:nvPr>
+        </p:nvSpPr>
+        <p:spPr>
+          <a:xfrm>
+            <a:off x="457200" y="822960"/>
+            <a:ext cx="8229600" cy="256032"/>
+          </a:xfrm>
+          <a:prstGeom prst="rect">
+            <a:avLst/>
+          </a:prstGeom>
+          <a:noFill/>
+          <a:ln/>
+        </p:spPr>
+        <p:txBody>
+          <a:bodyPr wrap="square" lIns="0" tIns="0" rIns="0" bIns="0" rtlCol="0" anchor="t"/>
+          <a:lstStyle/>
+          <a:p>
+            <a:pPr algn="l" indent="0" marL="0">
+              <a:buNone/>
+            </a:pPr>
+            <a:r>
+              <a:rPr lang="en-US" sz="1200" b="1" dirty="0">
+                <a:solidFill>
+                  <a:schemeClr val="accent1"/>
+                </a:solidFill>
+              </a:rPr>
+              <a:t>Technical Approach</a:t>
+            </a:r>
+            <a:pPr algn="l" indent="0" marL="0">
+              <a:buNone/>
+            </a:pPr>
+            <a:r>
+              <a:rPr lang="en-US" sz="1200" b="1" dirty="0">
+                <a:solidFill>
+                  <a:schemeClr val="accent2"/>
+                </a:solidFill>
+              </a:rPr>
+              <a:t>  ·  AI at every step</a:t>
+            </a:r>
+            <a:endParaRPr lang="en-US" sz="1200" dirty="0"/>
+          </a:p>
+        </p:txBody>
+      </p:sp>
+      <p:sp>
+        <p:nvSpPr>
+          <p:cNvPr id="3" name="Text 3"/>
+          <p:cNvSpPr/>
+          <p:nvPr>
+            <p:ph idx="106" type="title" hasCustomPrompt="1"/>
+          </p:nvPr>
+        </p:nvSpPr>
+        <p:spPr>
+          <a:xfrm>
+            <a:off x="457200" y="1069848"/>
+            <a:ext cx="8229600" cy="841248"/>
+          </a:xfrm>
+          <a:prstGeom prst="rect">
+            <a:avLst/>
+          </a:prstGeom>
+          <a:noFill/>
+          <a:ln/>
+        </p:spPr>
+        <p:txBody>
+          <a:bodyPr wrap="square" lIns="0" tIns="0" rIns="0" bIns="0" rtlCol="0" anchor="t"/>
+          <a:lstStyle/>
+          <a:p>
+            <a:pPr algn="l" indent="0" marL="0">
+              <a:buNone/>
+            </a:pPr>
+            <a:r>
+              <a:rPr lang="en-US" sz="2600" b="1" dirty="0">
+                <a:solidFill>
+                  <a:schemeClr val="tx1"/>
+                </a:solidFill>
+              </a:rPr>
+              <a:t>Gemini briefs, advises, summarises and reports.</a:t>
+            </a:r>
+            <a:endParaRPr lang="en-US" sz="2600" dirty="0"/>
+          </a:p>
+        </p:txBody>
+      </p:sp>
+      <p:sp>
+        <p:nvSpPr>
+          <p:cNvPr id="4" name="Shape 2"/>
+          <p:cNvSpPr/>
+          <p:nvPr/>
+        </p:nvSpPr>
+        <p:spPr>
+          <a:xfrm>
+            <a:off x="457200" y="2057400"/>
+            <a:ext cx="2834640" cy="2468880"/>
+          </a:xfrm>
+          <a:prstGeom prst="roundRect">
+            <a:avLst>
+              <a:gd name="adj" fmla="val 3704"/>
+            </a:avLst>
+          </a:prstGeom>
+          <a:solidFill>
+            <a:schemeClr val="accent4"/>
+          </a:solidFill>
+          <a:ln/>
+        </p:spPr>
+      </p:sp>
+      <p:sp>
+        <p:nvSpPr>
+          <p:cNvPr id="5" name="Text 3"/>
+          <p:cNvSpPr txBox="1"/>
+          <p:nvPr/>
+        </p:nvSpPr>
+        <p:spPr>
+          <a:xfrm>
+            <a:off x="713232" y="2286000"/>
+            <a:ext cx="2377440" cy="274320"/>
+          </a:xfrm>
+          <a:prstGeom prst="rect">
+            <a:avLst/>
+          </a:prstGeom>
+          <a:noFill/>
+          <a:ln/>
+        </p:spPr>
+        <p:txBody>
+          <a:bodyPr wrap="square" lIns="0" tIns="0" rIns="0" bIns="0" rtlCol="0" anchor="t"/>
+          <a:lstStyle/>
+          <a:p>
+            <a:pPr indent="0" marL="0">
+              <a:buNone/>
+            </a:pPr>
+            <a:r>
+              <a:rPr lang="en-US" sz="1300" b="1" spc="100" kern="0" dirty="0">
+                <a:solidFill>
+                  <a:schemeClr val="accent1"/>
+                </a:solidFill>
+              </a:rPr>
+              <a:t>Rules do the maths</a:t>
+            </a:r>
+            <a:endParaRPr lang="en-US" sz="1300" dirty="0"/>
+          </a:p>
+        </p:txBody>
+      </p:sp>
+      <p:sp>
+        <p:nvSpPr>
+          <p:cNvPr id="6" name="Text 4"/>
+          <p:cNvSpPr txBox="1"/>
+          <p:nvPr/>
+        </p:nvSpPr>
+        <p:spPr>
+          <a:xfrm>
+            <a:off x="713232" y="2651760"/>
+            <a:ext cx="2377440" cy="1691640"/>
+          </a:xfrm>
+          <a:prstGeom prst="rect">
+            <a:avLst/>
+          </a:prstGeom>
+          <a:noFill/>
+          <a:ln/>
+        </p:spPr>
+        <p:txBody>
+          <a:bodyPr wrap="square" lIns="0" tIns="0" rIns="0" bIns="0" rtlCol="0" anchor="t"/>
+          <a:lstStyle/>
+          <a:p>
+            <a:pPr indent="0" marL="0">
+              <a:buNone/>
+            </a:pPr>
+            <a:r>
+              <a:rPr lang="en-US" sz="1500" dirty="0">
+                <a:solidFill>
+                  <a:schemeClr val="tx1"/>
+                </a:solidFill>
+              </a:rPr>
+              <a:t>Every number comes from the rules engine. Gemini only writes the words, and rule-based text takes over if the AI is unavailable.</a:t>
+            </a:r>
+            <a:endParaRPr lang="en-US" sz="1900" dirty="0"/>
+          </a:p>
+        </p:txBody>
+      </p:sp>
+      <p:pic>
+        <p:nvPicPr>
+          <p:cNvPr id="65" name="Screenshot 5" descr="Gemini morning briefing, approver summary and automatic incident report"/>
+          <p:cNvPicPr>
+            <a:picLocks noChangeAspect="1"/>
+          </p:cNvPicPr>
+          <p:nvPr/>
+        </p:nvPicPr>
+        <p:blipFill>
+          <a:blip r:embed="rId2"/>
+          <a:stretch>
+            <a:fillRect/>
+          </a:stretch>
+        </p:blipFill>
+        <p:spPr>
+          <a:xfrm>
+            <a:off x="3566160" y="2057400"/>
+            <a:ext cx="4092951" cy="2468880"/>
+          </a:xfrm>
+          <a:prstGeom prst="rect">
+            <a:avLst/>
+          </a:prstGeom>
+          <a:ln w="9525">
+            <a:solidFill>
+              <a:srgbClr val="BFBFBF"/>
+            </a:solidFill>
+          </a:ln>
+        </p:spPr>
+      </p:pic>
+      <p:sp>
+        <p:nvSpPr>
+          <p:cNvPr id="25" name="Slide Number Placeholder 0"/>
+          <p:cNvSpPr>
+            <a:spLocks noGrp="1"/>
+          </p:cNvSpPr>
+          <p:nvPr>
+            <p:ph type="sldNum" sz="quarter" idx="4294967295"/>
+          </p:nvPr>
+        </p:nvSpPr>
+        <p:spPr>
+          <a:xfrm>
+            <a:off x="8229600" y="4754880"/>
+            <a:ext cx="457200" cy="228600"/>
+          </a:xfrm>
+          <a:prstGeom prst="rect">
+            <a:avLst/>
+          </a:prstGeom>
+          <a:extLst>
+            <a:ext uri="{C572A759-6A51-4108-AA02-DFA0A04FC94B}">
+              <ma14:wrappingTextBoxFlag xmlns:ma14="http://schemas.microsoft.com/office/mac/drawingml/2011/main" val="0"/>
+            </a:ext>
+          </a:extLst>
+        </p:spPr>
+        <p:txBody>
+          <a:bodyPr lIns="0" tIns="0" rIns="0" bIns="0" anchor="ctr"/>
+          <a:lstStyle>
+            <a:lvl1pPr>
+              <a:defRPr sz="1000">
+                <a:solidFill>
+                  <a:schemeClr val="accent2"/>
+                </a:solidFill>
+              </a:defRPr>
+            </a:lvl1pPr>
+          </a:lstStyle>
+          <a:p>
+            <a:pPr algn="r"/>
+            <a:fld id="{F7021451-1387-4CA6-816F-3879F97B5CBC}" type="slidenum">
+              <a:rPr b="0" lang="en-US"/>
+              <a:t>7</a:t>
             </a:fld>
             <a:endParaRPr lang="en-US"/>
           </a:p>
@@ -7367,7 +8839,7 @@
                             <a:schemeClr val="tx1"/>
                           </a:solidFill>
                         </a:rPr>
-                        <a:t>Port strike</a:t>
+                        <a:t>Sea freight delay (Chennai Port)</a:t>
                       </a:r>
                       <a:endParaRPr lang="en-US" sz="1500" dirty="0"/>
                     </a:p>
@@ -7407,57 +8879,7 @@
                             <a:schemeClr val="tx1"/>
                           </a:solidFill>
                         </a:rPr>
-                        <a:t>Shipment </a:t>
-                      </a:r>
-                      <a:pPr indent="0" marL="0">
-                        <a:buNone/>
-                      </a:pPr>
-                      <a:r>
-                        <a:rPr lang="en-US" sz="1500" dirty="0">
-                          <a:solidFill>
-                            <a:schemeClr val="tx1"/>
-                          </a:solidFill>
-                          <a:highlight>
-                            <a:srgbClr val="FFFF00"/>
-                          </a:highlight>
-                        </a:rPr>
-                        <a:t>[N days]</a:t>
-                      </a:r>
-                      <a:pPr indent="0" marL="0">
-                        <a:buNone/>
-                      </a:pPr>
-                      <a:r>
-                        <a:rPr lang="en-US" sz="1500" dirty="0">
-                          <a:solidFill>
-                            <a:schemeClr val="tx1"/>
-                          </a:solidFill>
-                        </a:rPr>
-                        <a:t> late, </a:t>
-                      </a:r>
-                      <a:pPr indent="0" marL="0">
-                        <a:buNone/>
-                      </a:pPr>
-                      <a:r>
-                        <a:rPr lang="en-US" sz="1500" dirty="0">
-                          <a:solidFill>
-                            <a:schemeClr val="tx1"/>
-                          </a:solidFill>
-                          <a:highlight>
-                            <a:srgbClr val="FFFF00"/>
-                          </a:highlight>
-                        </a:rPr>
-                        <a:t>[12]</a:t>
-                      </a:r>
-                      <a:pPr indent="0" marL="0">
-                        <a:buNone/>
-                      </a:pPr>
-                      <a:r>
-                        <a:rPr lang="en-US" sz="1500" dirty="0">
-                          <a:solidFill>
-                            <a:schemeClr val="tx1"/>
-                          </a:solidFill>
-                        </a:rPr>
-                        <a:t> orders short, premium customer at risk</a:t>
+                        <a:t>Shipment 5 days late; 3 orders (₹8.9 L) short, one Critical</a:t>
                       </a:r>
                       <a:endParaRPr lang="en-US" sz="1500" dirty="0"/>
                     </a:p>
@@ -7497,7 +8919,7 @@
                             <a:schemeClr val="tx1"/>
                           </a:solidFill>
                         </a:rPr>
-                        <a:t>Reallocate stock and split an order</a:t>
+                        <a:t>Move stock from Hyderabad, or expedite the shipment</a:t>
                       </a:r>
                       <a:endParaRPr lang="en-US" sz="1500" dirty="0"/>
                     </a:p>
@@ -7579,7 +9001,7 @@
                             <a:schemeClr val="tx1"/>
                           </a:solidFill>
                         </a:rPr>
-                        <a:t>Supplier factory outage</a:t>
+                        <a:t>Supplier shortfall (Mumbai)</a:t>
                       </a:r>
                       <a:endParaRPr lang="en-US" sz="1500" dirty="0"/>
                     </a:p>
@@ -7619,7 +9041,7 @@
                             <a:schemeClr val="tx1"/>
                           </a:solidFill>
                         </a:rPr>
-                        <a:t>No arrival date, no spare stock</a:t>
+                        <a:t>Mumbai stock short; 3 orders (₹12.0 L), one Critical</a:t>
                       </a:r>
                       <a:endParaRPr lang="en-US" sz="1500" dirty="0"/>
                     </a:p>
@@ -7659,7 +9081,7 @@
                             <a:schemeClr val="tx1"/>
                           </a:solidFill>
                         </a:rPr>
-                        <a:t>Alternative supplier plus expedite</a:t>
+                        <a:t>Move stock from Hyderabad; free split options flagged ⚠</a:t>
                       </a:r>
                       <a:endParaRPr lang="en-US" sz="1500" dirty="0"/>
                     </a:p>
@@ -7699,7 +9121,7 @@
                             <a:schemeClr val="tx2"/>
                           </a:solidFill>
                         </a:rPr>
-                        <a:t>Procurement Approver</a:t>
+                        <a:t>Supply Chain Manager</a:t>
                       </a:r>
                       <a:endParaRPr lang="en-US" sz="1500" dirty="0"/>
                     </a:p>
@@ -7834,6 +9256,17 @@
               </a:rPr>
               <a:t>Technical Approach</a:t>
             </a:r>
+            <a:pPr algn="l" indent="0" marL="0">
+              <a:buNone/>
+            </a:pPr>
+            <a:r>
+              <a:rPr lang="en-US" sz="1200" b="1" dirty="0">
+                <a:solidFill>
+                  <a:schemeClr val="accent2"/>
+                </a:solidFill>
+              </a:rPr>
+              <a:t>  ·  Our novelty</a:t>
+            </a:r>
             <a:endParaRPr lang="en-US" sz="1200" dirty="0"/>
           </a:p>
         </p:txBody>
@@ -7870,73 +9303,9 @@
                   <a:schemeClr val="tx1"/>
                 </a:solidFill>
               </a:rPr>
-              <a:t>Every ranking explains itself.</a:t>
+              <a:t>Do-no-harm recovery: no fix starts the next disruption.</a:t>
             </a:r>
             <a:endParaRPr lang="en-US" sz="2600" dirty="0"/>
-          </a:p>
-        </p:txBody>
-      </p:sp>
-      <p:sp>
-        <p:nvSpPr>
-          <p:cNvPr id="4" name="Shape 2"/>
-          <p:cNvSpPr/>
-          <p:nvPr/>
-        </p:nvSpPr>
-        <p:spPr>
-          <a:xfrm>
-            <a:off x="457200" y="2057400"/>
-            <a:ext cx="5257800" cy="2468880"/>
-          </a:xfrm>
-          <a:prstGeom prst="rect">
-            <a:avLst/>
-          </a:prstGeom>
-          <a:solidFill>
-            <a:schemeClr val="accent6"/>
-          </a:solidFill>
-          <a:ln w="15875">
-            <a:solidFill>
-              <a:schemeClr val="accent5"/>
-            </a:solidFill>
-            <a:prstDash val="dash"/>
-          </a:ln>
-        </p:spPr>
-      </p:sp>
-      <p:sp>
-        <p:nvSpPr>
-          <p:cNvPr id="5" name="Text 3"/>
-          <p:cNvSpPr txBox="1"/>
-          <p:nvPr/>
-        </p:nvSpPr>
-        <p:spPr>
-          <a:xfrm>
-            <a:off x="1165860" y="2057400"/>
-            <a:ext cx="3840480" cy="2468880"/>
-          </a:xfrm>
-          <a:prstGeom prst="rect">
-            <a:avLst/>
-          </a:prstGeom>
-          <a:noFill/>
-          <a:ln/>
-        </p:spPr>
-        <p:txBody>
-          <a:bodyPr wrap="square" lIns="0" tIns="0" rIns="0" bIns="0" rtlCol="0" anchor="ctr"/>
-          <a:lstStyle/>
-          <a:p>
-            <a:pPr algn="ctr" indent="0" marL="0">
-              <a:buNone/>
-            </a:pPr>
-            <a:r>
-              <a:rPr lang="en-US" sz="1400" b="1" dirty="0">
-                <a:solidFill>
-                  <a:schemeClr val="tx1"/>
-                </a:solidFill>
-                <a:highlight>
-                  <a:srgbClr val="FFFF00"/>
-                </a:highlight>
-              </a:rPr>
-              <a:t>[SCREENSHOT: ranked orders table with factor breakdown]</a:t>
-            </a:r>
-            <a:endParaRPr lang="en-US" sz="1400" dirty="0"/>
           </a:p>
         </p:txBody>
       </p:sp>
@@ -7970,7 +9339,7 @@
                   <a:schemeClr val="accent2"/>
                 </a:solidFill>
               </a:rPr>
-              <a:t>Each score shows five factors</a:t>
+              <a:t>Before anyone approves</a:t>
             </a:r>
             <a:endParaRPr lang="en-US" sz="1500" dirty="0"/>
           </a:p>
@@ -8026,7 +9395,7 @@
                   <a:schemeClr val="tx1"/>
                 </a:solidFill>
               </a:rPr>
-              <a:t>Days of slack</a:t>
+              <a:t>Side effects checked</a:t>
             </a:r>
             <a:endParaRPr lang="en-US" sz="1700" dirty="0"/>
           </a:p>
@@ -8082,7 +9451,7 @@
                   <a:schemeClr val="tx1"/>
                 </a:solidFill>
               </a:rPr>
-              <a:t>Size of shortage</a:t>
+              <a:t>Risky sources skipped</a:t>
             </a:r>
             <a:endParaRPr lang="en-US" sz="1700" dirty="0"/>
           </a:p>
@@ -8138,7 +9507,7 @@
                   <a:schemeClr val="tx1"/>
                 </a:solidFill>
               </a:rPr>
-              <a:t>Customer tier</a:t>
+              <a:t>Harmful fixes go last</a:t>
             </a:r>
             <a:endParaRPr lang="en-US" sz="1700" dirty="0"/>
           </a:p>
@@ -8194,7 +9563,7 @@
                   <a:schemeClr val="tx1"/>
                 </a:solidFill>
               </a:rPr>
-              <a:t>Penalty exposure</a:t>
+              <a:t>Fix previewed on a map</a:t>
             </a:r>
             <a:endParaRPr lang="en-US" sz="1700" dirty="0"/>
           </a:p>
@@ -8250,12 +9619,41 @@
                   <a:schemeClr val="tx1"/>
                 </a:solidFill>
               </a:rPr>
-              <a:t>Supplier reliability</a:t>
+              <a:t>Re-checked at approval</a:t>
             </a:r>
             <a:endParaRPr lang="en-US" sz="1700" dirty="0"/>
           </a:p>
         </p:txBody>
       </p:sp>
+      <p:pic>
+        <p:nvPicPr>
+          <p:cNvPr id="61" name="Screenshot 1" descr="Recovery options with do-no-harm labels and a map preview of a fix that would leave another order short"/>
+          <p:cNvPicPr>
+            <a:picLocks noChangeAspect="1"/>
+          </p:cNvPicPr>
+          <p:nvPr/>
+        </p:nvPicPr>
+        <p:blipFill>
+          <a:blip r:embed="rId3"/>
+          <a:stretch>
+            <a:fillRect/>
+          </a:stretch>
+        </p:blipFill>
+        <p:spPr>
+          <a:xfrm>
+            <a:off x="457200" y="2520581"/>
+            <a:ext cx="5257800" cy="1542518"/>
+          </a:xfrm>
+          <a:prstGeom prst="rect">
+            <a:avLst/>
+          </a:prstGeom>
+          <a:ln w="9525">
+            <a:solidFill>
+              <a:srgbClr val="BFBFBF"/>
+            </a:solidFill>
+          </a:ln>
+        </p:spPr>
+      </p:pic>
       <p:sp>
         <p:nvSpPr>
           <p:cNvPr id="25" name="Slide Number Placeholder 0"/>
@@ -8360,6 +9758,17 @@
               </a:rPr>
               <a:t>Technical Approach</a:t>
             </a:r>
+            <a:pPr algn="l" indent="0" marL="0">
+              <a:buNone/>
+            </a:pPr>
+            <a:r>
+              <a:rPr lang="en-US" sz="1200" b="1" dirty="0">
+                <a:solidFill>
+                  <a:schemeClr val="accent2"/>
+                </a:solidFill>
+              </a:rPr>
+              <a:t>  ·  AI suggestion</a:t>
+            </a:r>
             <a:endParaRPr lang="en-US" sz="1200" dirty="0"/>
           </a:p>
         </p:txBody>
@@ -8396,7 +9805,7 @@
                   <a:schemeClr val="tx1"/>
                 </a:solidFill>
               </a:rPr>
-              <a:t>AI explains the options. Rules prove they are feasible.</a:t>
+              <a:t>AI picks from options the rules built and checked.</a:t>
             </a:r>
             <a:endParaRPr lang="en-US" sz="2600" dirty="0"/>
           </a:p>
@@ -8485,81 +9894,46 @@
               <a:buNone/>
             </a:pPr>
             <a:r>
-              <a:rPr lang="en-US" sz="1900" dirty="0">
+              <a:rPr lang="en-US" sz="1500" dirty="0">
                 <a:solidFill>
                   <a:schemeClr val="tx1"/>
                 </a:solidFill>
               </a:rPr>
-              <a:t>AI can only choose from options the rules built, so it cannot invent stock or suppliers.</a:t>
+              <a:t>Gemini can only recommend option numbers the rules built and checked. Its picks are highlighted as “AI suggested”; a person still chooses.</a:t>
             </a:r>
             <a:endParaRPr lang="en-US" sz="1900" dirty="0"/>
           </a:p>
         </p:txBody>
       </p:sp>
-      <p:sp>
-        <p:nvSpPr>
-          <p:cNvPr id="7" name="Shape 5"/>
-          <p:cNvSpPr/>
-          <p:nvPr/>
-        </p:nvSpPr>
-        <p:spPr>
-          <a:xfrm>
-            <a:off x="3566160" y="2057400"/>
-            <a:ext cx="5120640" cy="2468880"/>
-          </a:xfrm>
-          <a:prstGeom prst="rect">
-            <a:avLst/>
-          </a:prstGeom>
-          <a:solidFill>
-            <a:schemeClr val="accent6"/>
-          </a:solidFill>
-          <a:ln w="15875">
+      <p:pic>
+        <p:nvPicPr>
+          <p:cNvPr id="62" name="Screenshot 2" descr="Recovery options window with Gemini advice and the options it recommends highlighted as AI suggested"/>
+          <p:cNvPicPr>
+            <a:picLocks noChangeAspect="1"/>
+          </p:cNvPicPr>
+          <p:nvPr/>
+        </p:nvPicPr>
+        <p:blipFill>
+          <a:blip r:embed="rId3"/>
+          <a:stretch>
+            <a:fillRect/>
+          </a:stretch>
+        </p:blipFill>
+        <p:spPr>
+          <a:xfrm>
+            <a:off x="3566160" y="2387600"/>
+            <a:ext cx="5120640" cy="1808480"/>
+          </a:xfrm>
+          <a:prstGeom prst="rect">
+            <a:avLst/>
+          </a:prstGeom>
+          <a:ln w="9525">
             <a:solidFill>
-              <a:schemeClr val="accent5"/>
+              <a:srgbClr val="BFBFBF"/>
             </a:solidFill>
-            <a:prstDash val="dash"/>
           </a:ln>
         </p:spPr>
-      </p:sp>
-      <p:sp>
-        <p:nvSpPr>
-          <p:cNvPr id="8" name="Text 6"/>
-          <p:cNvSpPr txBox="1"/>
-          <p:nvPr/>
-        </p:nvSpPr>
-        <p:spPr>
-          <a:xfrm>
-            <a:off x="4206240" y="2057400"/>
-            <a:ext cx="3840480" cy="2468880"/>
-          </a:xfrm>
-          <a:prstGeom prst="rect">
-            <a:avLst/>
-          </a:prstGeom>
-          <a:noFill/>
-          <a:ln/>
-        </p:spPr>
-        <p:txBody>
-          <a:bodyPr wrap="square" lIns="0" tIns="0" rIns="0" bIns="0" rtlCol="0" anchor="ctr"/>
-          <a:lstStyle/>
-          <a:p>
-            <a:pPr algn="ctr" indent="0" marL="0">
-              <a:buNone/>
-            </a:pPr>
-            <a:r>
-              <a:rPr lang="en-US" sz="1400" b="1" dirty="0">
-                <a:solidFill>
-                  <a:schemeClr val="tx1"/>
-                </a:solidFill>
-                <a:highlight>
-                  <a:srgbClr val="FFFF00"/>
-                </a:highlight>
-              </a:rPr>
-              <a:t>[SCREENSHOT: recovery options with cost, speed and orders saved]</a:t>
-            </a:r>
-            <a:endParaRPr lang="en-US" sz="1400" dirty="0"/>
-          </a:p>
-        </p:txBody>
-      </p:sp>
+      </p:pic>
       <p:sp>
         <p:nvSpPr>
           <p:cNvPr id="25" name="Slide Number Placeholder 0"/>
@@ -9139,7 +10513,7 @@
                 <a:ea typeface="+mj-lt" pitchFamily="34" charset="-122"/>
                 <a:cs typeface="+mj-lt" pitchFamily="34" charset="-120"/>
               </a:rPr>
-              <a:t>Enforced on the server</a:t>
+              <a:t>Enforced by the rules</a:t>
             </a:r>
             <a:endParaRPr lang="en-US" sz="1900" dirty="0"/>
           </a:p>
@@ -9742,11 +11116,8 @@
                 <a:solidFill>
                   <a:schemeClr val="tx1"/>
                 </a:solidFill>
-                <a:highlight>
-                  <a:srgbClr val="FFFF00"/>
-                </a:highlight>
-              </a:rPr>
-              <a:t>[CONFIRM BUILT]</a:t>
+              </a:rPr>
+              <a:t>✓ Live in demo</a:t>
             </a:r>
             <a:endParaRPr lang="en-US" sz="1000" dirty="0"/>
           </a:p>
@@ -9804,7 +11175,7 @@
                   <a:schemeClr val="tx1"/>
                 </a:solidFill>
               </a:rPr>
-              <a:t>Risk scores that show their reasons</a:t>
+              <a:t>Do-no-harm recovery</a:t>
             </a:r>
             <a:endParaRPr lang="en-US" sz="1500" dirty="0"/>
           </a:p>
@@ -9839,11 +11210,8 @@
                 <a:solidFill>
                   <a:schemeClr val="tx1"/>
                 </a:solidFill>
-                <a:highlight>
-                  <a:srgbClr val="FFFF00"/>
-                </a:highlight>
-              </a:rPr>
-              <a:t>[CONFIRM BUILT]</a:t>
+              </a:rPr>
+              <a:t>✓ Live in demo</a:t>
             </a:r>
             <a:endParaRPr lang="en-US" sz="1000" dirty="0"/>
           </a:p>
@@ -9936,11 +11304,8 @@
                 <a:solidFill>
                   <a:schemeClr val="tx1"/>
                 </a:solidFill>
-                <a:highlight>
-                  <a:srgbClr val="FFFF00"/>
-                </a:highlight>
-              </a:rPr>
-              <a:t>[CONFIRM BUILT]</a:t>
+              </a:rPr>
+              <a:t>✓ Live in demo</a:t>
             </a:r>
             <a:endParaRPr lang="en-US" sz="1000" dirty="0"/>
           </a:p>
@@ -10033,11 +11398,8 @@
                 <a:solidFill>
                   <a:schemeClr val="tx1"/>
                 </a:solidFill>
-                <a:highlight>
-                  <a:srgbClr val="FFFF00"/>
-                </a:highlight>
-              </a:rPr>
-              <a:t>[CONFIRM BUILT]</a:t>
+              </a:rPr>
+              <a:t>✓ Live in demo</a:t>
             </a:r>
             <a:endParaRPr lang="en-US" sz="1000" dirty="0"/>
           </a:p>
@@ -10130,11 +11492,8 @@
                 <a:solidFill>
                   <a:schemeClr val="tx1"/>
                 </a:solidFill>
-                <a:highlight>
-                  <a:srgbClr val="FFFF00"/>
-                </a:highlight>
-              </a:rPr>
-              <a:t>[CONFIRM BUILT]</a:t>
+              </a:rPr>
+              <a:t>✓ Live in demo</a:t>
             </a:r>
             <a:endParaRPr lang="en-US" sz="1000" dirty="0"/>
           </a:p>
@@ -10170,7 +11529,7 @@
                   <a:schemeClr val="accent2"/>
                 </a:solidFill>
               </a:rPr>
-              <a:t>Also (only if built)</a:t>
+              <a:t>Also live in the demo</a:t>
             </a:r>
             <a:endParaRPr lang="en-US" sz="1300" dirty="0"/>
           </a:p>
@@ -10232,11 +11591,8 @@
                 <a:solidFill>
                   <a:schemeClr val="tx1"/>
                 </a:solidFill>
-                <a:highlight>
-                  <a:srgbClr val="FFFF00"/>
-                </a:highlight>
-              </a:rPr>
-              <a:t>[blast-radius graph]</a:t>
+              </a:rPr>
+              <a:t>Stress test</a:t>
             </a:r>
             <a:endParaRPr lang="en-US" sz="1500" dirty="0"/>
           </a:p>
@@ -10298,11 +11654,8 @@
                 <a:solidFill>
                   <a:schemeClr val="tx1"/>
                 </a:solidFill>
-                <a:highlight>
-                  <a:srgbClr val="FFFF00"/>
-                </a:highlight>
-              </a:rPr>
-              <a:t>[what-if simulator]</a:t>
+              </a:rPr>
+              <a:t>Ripple replay</a:t>
             </a:r>
             <a:endParaRPr lang="en-US" sz="1500" dirty="0"/>
           </a:p>
@@ -10364,11 +11717,8 @@
                 <a:solidFill>
                   <a:schemeClr val="tx1"/>
                 </a:solidFill>
-                <a:highlight>
-                  <a:srgbClr val="FFFF00"/>
-                </a:highlight>
-              </a:rPr>
-              <a:t>[supplier reliability score]</a:t>
+              </a:rPr>
+              <a:t>Fix preview on the map</a:t>
             </a:r>
             <a:endParaRPr lang="en-US" sz="1500" dirty="0"/>
           </a:p>

</xml_diff>

<commit_message>
Deck: add "Necessity first" risk-priority slide
New slide 7 after the do-no-harm slide: a hospital outranks a premium
subscription. Live screenshot of the life-critical alert header, need-
ranked orders (ICU monitors 97 vs premium subscription 30) and a fix
blocked for taking a hospital order's stock, with speaker notes.

Co-Authored-By: Claude Opus 5.5 <noreply@anthropic.com>
</commit_message>
<xml_diff>
--- a/docs/DisruptionIQ_Overclock26.pptx
+++ b/docs/DisruptionIQ_Overclock26.pptx
@@ -11,6 +11,7 @@
     <p:sldId id="259" r:id="rId5"/>
     <p:sldId id="260" r:id="rId6"/>
     <p:sldId id="261" r:id="rId7"/>
+    <p:sldId id="270" r:id="rId21"/>
     <p:sldId id="262" r:id="rId8"/>
     <p:sldId id="267" r:id="rId18"/>
     <p:sldId id="268" r:id="rId19"/>
@@ -1004,6 +1005,94 @@
             <a:r>
               <a:rPr lang="en-US" dirty="0"/>
               <a:t>Gemini 3.5 Flash-Lite works at every step: a morning briefing written for each role, a plain-English summary for the approver of what a plan commits to and what to check, and an incident report written automatically when a disruption is resolved and saved to the audit log. The rules work out every number; the AI only writes the words.</a:t>
+            </a:r>
+            <a:endParaRPr lang="en-US" dirty="0"/>
+          </a:p>
+        </p:txBody>
+      </p:sp>
+      <p:sp>
+        <p:nvSpPr>
+          <p:cNvPr id="4" name="Slide Number Placeholder 3"/>
+          <p:cNvSpPr>
+            <a:spLocks noGrp="1"/>
+          </p:cNvSpPr>
+          <p:nvPr>
+            <p:ph type="sldNum" sz="quarter" idx="10"/>
+          </p:nvPr>
+        </p:nvSpPr>
+        <p:spPr/>
+        <p:txBody>
+          <a:bodyPr/>
+          <a:lstStyle/>
+          <a:p>
+            <a:fld id="{F7021451-1387-4CA6-816F-3879F97B5CBC}" type="slidenum">
+              <a:rPr lang="en-US"/>
+              <a:t>6</a:t>
+            </a:fld>
+            <a:endParaRPr lang="en-US"/>
+          </a:p>
+        </p:txBody>
+      </p:sp>
+    </p:spTree>
+    <p:extLst>
+      <p:ext uri="{BB962C8B-B14F-4D97-AF65-F5344CB8AC3E}">
+        <p14:creationId xmlns:p14="http://schemas.microsoft.com/office/powerpoint/2010/main" val="1024086991"/>
+      </p:ext>
+    </p:extLst>
+  </p:cSld>
+  <p:clrMapOvr>
+    <a:masterClrMapping/>
+  </p:clrMapOvr>
+</p:notes>
+</file>
+
+<file path=ppt/notesSlides/notesSlide15.xml><?xml version="1.0" encoding="utf-8"?>
+<p:notes xmlns:a="http://schemas.openxmlformats.org/drawingml/2006/main" xmlns:r="http://schemas.openxmlformats.org/officeDocument/2006/relationships" xmlns:p="http://schemas.openxmlformats.org/presentationml/2006/main">
+  <p:cSld>
+    <p:spTree>
+      <p:nvGrpSpPr>
+        <p:cNvPr id="1" name=""/>
+        <p:cNvGrpSpPr/>
+        <p:nvPr/>
+      </p:nvGrpSpPr>
+      <p:grpSpPr>
+        <a:xfrm>
+          <a:off x="0" y="0"/>
+          <a:ext cx="0" cy="0"/>
+          <a:chOff x="0" y="0"/>
+          <a:chExt cx="0" cy="0"/>
+        </a:xfrm>
+      </p:grpSpPr>
+      <p:sp>
+        <p:nvSpPr>
+          <p:cNvPr id="2" name="Slide Image Placeholder 1"/>
+          <p:cNvSpPr>
+            <a:spLocks noGrp="1" noRot="1" noChangeAspect="1"/>
+          </p:cNvSpPr>
+          <p:nvPr>
+            <p:ph type="sldImg"/>
+          </p:nvPr>
+        </p:nvSpPr>
+        <p:spPr/>
+      </p:sp>
+      <p:sp>
+        <p:nvSpPr>
+          <p:cNvPr id="3" name="Notes Placeholder 2"/>
+          <p:cNvSpPr>
+            <a:spLocks noGrp="1"/>
+          </p:cNvSpPr>
+          <p:nvPr>
+            <p:ph type="body" idx="1"/>
+          </p:nvPr>
+        </p:nvSpPr>
+        <p:spPr/>
+        <p:txBody>
+          <a:bodyPr/>
+          <a:lstStyle/>
+          <a:p>
+            <a:r>
+              <a:rPr lang="en-US" dirty="0"/>
+              <a:t>Who should be helped first: a hospital's ICU monitors or a premium subscription? DisruptionIQ ranks recovery by necessity: life-critical healthcare deliveries first, then essential services like food and energy, then operational and commercial orders, and only then urgency, contract priority and value. Here Pioneer Labs has a Critical premium contract, yet scores 30 while Nova Medical's ICU monitors score 97. A red header pops up on every page with Recover now, and any fix that would take stock the hospital needs is blocked outright.</a:t>
             </a:r>
             <a:endParaRPr lang="en-US" dirty="0"/>
           </a:p>
@@ -5908,6 +5997,508 @@
             <a:fld id="{F7021451-1387-4CA6-816F-3879F97B5CBC}" type="slidenum">
               <a:rPr b="0" lang="en-US"/>
               <a:t>7</a:t>
+            </a:fld>
+            <a:endParaRPr lang="en-US"/>
+          </a:p>
+        </p:txBody>
+      </p:sp>
+    </p:spTree>
+  </p:cSld>
+  <p:clrMapOvr>
+    <a:masterClrMapping/>
+  </p:clrMapOvr>
+</p:sld>
+</file>
+
+<file path=ppt/slides/slide15.xml><?xml version="1.0" encoding="utf-8"?>
+<p:sld xmlns:a="http://schemas.openxmlformats.org/drawingml/2006/main" xmlns:r="http://schemas.openxmlformats.org/officeDocument/2006/relationships" xmlns:p="http://schemas.openxmlformats.org/presentationml/2006/main">
+  <p:cSld name="Slide 6">
+    <p:spTree>
+      <p:nvGrpSpPr>
+        <p:cNvPr id="1" name=""/>
+        <p:cNvGrpSpPr/>
+        <p:nvPr/>
+      </p:nvGrpSpPr>
+      <p:grpSpPr>
+        <a:xfrm>
+          <a:off x="0" y="0"/>
+          <a:ext cx="0" cy="0"/>
+          <a:chOff x="0" y="0"/>
+          <a:chExt cx="0" cy="0"/>
+        </a:xfrm>
+      </p:grpSpPr>
+      <p:sp>
+        <p:nvSpPr>
+          <p:cNvPr id="2" name="Text 3"/>
+          <p:cNvSpPr/>
+          <p:nvPr>
+            <p:ph idx="105" type="body" hasCustomPrompt="1"/>
+          </p:nvPr>
+        </p:nvSpPr>
+        <p:spPr>
+          <a:xfrm>
+            <a:off x="457200" y="822960"/>
+            <a:ext cx="8229600" cy="256032"/>
+          </a:xfrm>
+          <a:prstGeom prst="rect">
+            <a:avLst/>
+          </a:prstGeom>
+          <a:noFill/>
+          <a:ln/>
+        </p:spPr>
+        <p:txBody>
+          <a:bodyPr wrap="square" lIns="0" tIns="0" rIns="0" bIns="0" rtlCol="0" anchor="t"/>
+          <a:lstStyle/>
+          <a:p>
+            <a:pPr algn="l" indent="0" marL="0">
+              <a:buNone/>
+            </a:pPr>
+            <a:r>
+              <a:rPr lang="en-US" sz="1200" b="1" dirty="0">
+                <a:solidFill>
+                  <a:schemeClr val="accent1"/>
+                </a:solidFill>
+              </a:rPr>
+              <a:t>Technical Approach</a:t>
+            </a:r>
+            <a:pPr algn="l" indent="0" marL="0">
+              <a:buNone/>
+            </a:pPr>
+            <a:r>
+              <a:rPr lang="en-US" sz="1200" b="1" dirty="0">
+                <a:solidFill>
+                  <a:schemeClr val="accent2"/>
+                </a:solidFill>
+              </a:rPr>
+              <a:t>  ·  Risk priority</a:t>
+            </a:r>
+            <a:endParaRPr lang="en-US" sz="1200" dirty="0"/>
+          </a:p>
+        </p:txBody>
+      </p:sp>
+      <p:sp>
+        <p:nvSpPr>
+          <p:cNvPr id="3" name="Text 3"/>
+          <p:cNvSpPr/>
+          <p:nvPr>
+            <p:ph idx="106" type="title" hasCustomPrompt="1"/>
+          </p:nvPr>
+        </p:nvSpPr>
+        <p:spPr>
+          <a:xfrm>
+            <a:off x="457200" y="1069848"/>
+            <a:ext cx="8229600" cy="841248"/>
+          </a:xfrm>
+          <a:prstGeom prst="rect">
+            <a:avLst/>
+          </a:prstGeom>
+          <a:noFill/>
+          <a:ln/>
+        </p:spPr>
+        <p:txBody>
+          <a:bodyPr wrap="square" lIns="0" tIns="0" rIns="0" bIns="0" rtlCol="0" anchor="t"/>
+          <a:lstStyle/>
+          <a:p>
+            <a:pPr algn="l" indent="0" marL="0">
+              <a:buNone/>
+            </a:pPr>
+            <a:r>
+              <a:rPr lang="en-US" sz="2600" b="1" dirty="0">
+                <a:solidFill>
+                  <a:schemeClr val="tx1"/>
+                </a:solidFill>
+              </a:rPr>
+              <a:t>Necessity first: a hospital outranks a premium subscription.</a:t>
+            </a:r>
+            <a:endParaRPr lang="en-US" sz="2600" dirty="0"/>
+          </a:p>
+        </p:txBody>
+      </p:sp>
+      <p:sp>
+        <p:nvSpPr>
+          <p:cNvPr id="6" name="Text 4"/>
+          <p:cNvSpPr txBox="1"/>
+          <p:nvPr/>
+        </p:nvSpPr>
+        <p:spPr>
+          <a:xfrm>
+            <a:off x="6080760" y="2103120"/>
+            <a:ext cx="2606040" cy="320040"/>
+          </a:xfrm>
+          <a:prstGeom prst="rect">
+            <a:avLst/>
+          </a:prstGeom>
+          <a:noFill/>
+          <a:ln/>
+        </p:spPr>
+        <p:txBody>
+          <a:bodyPr wrap="square" lIns="0" tIns="0" rIns="0" bIns="0" rtlCol="0" anchor="t"/>
+          <a:lstStyle/>
+          <a:p>
+            <a:pPr indent="0" marL="0">
+              <a:buNone/>
+            </a:pPr>
+            <a:r>
+              <a:rPr lang="en-US" sz="1500" b="1" dirty="0">
+                <a:solidFill>
+                  <a:schemeClr val="accent2"/>
+                </a:solidFill>
+              </a:rPr>
+              <a:t>Need before value</a:t>
+            </a:r>
+            <a:endParaRPr lang="en-US" sz="1500" dirty="0"/>
+          </a:p>
+        </p:txBody>
+      </p:sp>
+      <p:sp>
+        <p:nvSpPr>
+          <p:cNvPr id="7" name="Shape 5"/>
+          <p:cNvSpPr/>
+          <p:nvPr/>
+        </p:nvSpPr>
+        <p:spPr>
+          <a:xfrm>
+            <a:off x="6080760" y="2706624"/>
+            <a:ext cx="109728" cy="109728"/>
+          </a:xfrm>
+          <a:prstGeom prst="ellipse">
+            <a:avLst/>
+          </a:prstGeom>
+          <a:solidFill>
+            <a:schemeClr val="accent1"/>
+          </a:solidFill>
+          <a:ln/>
+        </p:spPr>
+      </p:sp>
+      <p:sp>
+        <p:nvSpPr>
+          <p:cNvPr id="8" name="Text 6"/>
+          <p:cNvSpPr txBox="1"/>
+          <p:nvPr/>
+        </p:nvSpPr>
+        <p:spPr>
+          <a:xfrm>
+            <a:off x="6327648" y="2606040"/>
+            <a:ext cx="2377440" cy="310896"/>
+          </a:xfrm>
+          <a:prstGeom prst="rect">
+            <a:avLst/>
+          </a:prstGeom>
+          <a:noFill/>
+          <a:ln/>
+        </p:spPr>
+        <p:txBody>
+          <a:bodyPr wrap="square" lIns="0" tIns="0" rIns="0" bIns="0" rtlCol="0" anchor="ctr"/>
+          <a:lstStyle/>
+          <a:p>
+            <a:pPr indent="0" marL="0">
+              <a:buNone/>
+            </a:pPr>
+            <a:r>
+              <a:rPr lang="en-US" sz="1700" dirty="0">
+                <a:solidFill>
+                  <a:schemeClr val="tx1"/>
+                </a:solidFill>
+              </a:rPr>
+              <a:t>Life-critical first</a:t>
+            </a:r>
+            <a:endParaRPr lang="en-US" sz="1700" dirty="0"/>
+          </a:p>
+        </p:txBody>
+      </p:sp>
+      <p:sp>
+        <p:nvSpPr>
+          <p:cNvPr id="9" name="Shape 7"/>
+          <p:cNvSpPr/>
+          <p:nvPr/>
+        </p:nvSpPr>
+        <p:spPr>
+          <a:xfrm>
+            <a:off x="6080760" y="3099816"/>
+            <a:ext cx="109728" cy="109728"/>
+          </a:xfrm>
+          <a:prstGeom prst="ellipse">
+            <a:avLst/>
+          </a:prstGeom>
+          <a:solidFill>
+            <a:schemeClr val="accent1"/>
+          </a:solidFill>
+          <a:ln/>
+        </p:spPr>
+      </p:sp>
+      <p:sp>
+        <p:nvSpPr>
+          <p:cNvPr id="10" name="Text 8"/>
+          <p:cNvSpPr txBox="1"/>
+          <p:nvPr/>
+        </p:nvSpPr>
+        <p:spPr>
+          <a:xfrm>
+            <a:off x="6327648" y="2999232"/>
+            <a:ext cx="2377440" cy="310896"/>
+          </a:xfrm>
+          <a:prstGeom prst="rect">
+            <a:avLst/>
+          </a:prstGeom>
+          <a:noFill/>
+          <a:ln/>
+        </p:spPr>
+        <p:txBody>
+          <a:bodyPr wrap="square" lIns="0" tIns="0" rIns="0" bIns="0" rtlCol="0" anchor="ctr"/>
+          <a:lstStyle/>
+          <a:p>
+            <a:pPr indent="0" marL="0">
+              <a:buNone/>
+            </a:pPr>
+            <a:r>
+              <a:rPr lang="en-US" sz="1700" dirty="0">
+                <a:solidFill>
+                  <a:schemeClr val="tx1"/>
+                </a:solidFill>
+              </a:rPr>
+              <a:t>Then essential needs</a:t>
+            </a:r>
+            <a:endParaRPr lang="en-US" sz="1700" dirty="0"/>
+          </a:p>
+        </p:txBody>
+      </p:sp>
+      <p:sp>
+        <p:nvSpPr>
+          <p:cNvPr id="11" name="Shape 9"/>
+          <p:cNvSpPr/>
+          <p:nvPr/>
+        </p:nvSpPr>
+        <p:spPr>
+          <a:xfrm>
+            <a:off x="6080760" y="3493008"/>
+            <a:ext cx="109728" cy="109728"/>
+          </a:xfrm>
+          <a:prstGeom prst="ellipse">
+            <a:avLst/>
+          </a:prstGeom>
+          <a:solidFill>
+            <a:schemeClr val="accent1"/>
+          </a:solidFill>
+          <a:ln/>
+        </p:spPr>
+      </p:sp>
+      <p:sp>
+        <p:nvSpPr>
+          <p:cNvPr id="12" name="Text 10"/>
+          <p:cNvSpPr txBox="1"/>
+          <p:nvPr/>
+        </p:nvSpPr>
+        <p:spPr>
+          <a:xfrm>
+            <a:off x="6327648" y="3392424"/>
+            <a:ext cx="2377440" cy="310896"/>
+          </a:xfrm>
+          <a:prstGeom prst="rect">
+            <a:avLst/>
+          </a:prstGeom>
+          <a:noFill/>
+          <a:ln/>
+        </p:spPr>
+        <p:txBody>
+          <a:bodyPr wrap="square" lIns="0" tIns="0" rIns="0" bIns="0" rtlCol="0" anchor="ctr"/>
+          <a:lstStyle/>
+          <a:p>
+            <a:pPr indent="0" marL="0">
+              <a:buNone/>
+            </a:pPr>
+            <a:r>
+              <a:rPr lang="en-US" sz="1700" dirty="0">
+                <a:solidFill>
+                  <a:schemeClr val="tx1"/>
+                </a:solidFill>
+              </a:rPr>
+              <a:t>Then urgency, contract</a:t>
+            </a:r>
+            <a:endParaRPr lang="en-US" sz="1700" dirty="0"/>
+          </a:p>
+        </p:txBody>
+      </p:sp>
+      <p:sp>
+        <p:nvSpPr>
+          <p:cNvPr id="13" name="Shape 11"/>
+          <p:cNvSpPr/>
+          <p:nvPr/>
+        </p:nvSpPr>
+        <p:spPr>
+          <a:xfrm>
+            <a:off x="6080760" y="3886200"/>
+            <a:ext cx="109728" cy="109728"/>
+          </a:xfrm>
+          <a:prstGeom prst="ellipse">
+            <a:avLst/>
+          </a:prstGeom>
+          <a:solidFill>
+            <a:schemeClr val="accent1"/>
+          </a:solidFill>
+          <a:ln/>
+        </p:spPr>
+      </p:sp>
+      <p:sp>
+        <p:nvSpPr>
+          <p:cNvPr id="14" name="Text 12"/>
+          <p:cNvSpPr txBox="1"/>
+          <p:nvPr/>
+        </p:nvSpPr>
+        <p:spPr>
+          <a:xfrm>
+            <a:off x="6327648" y="3785616"/>
+            <a:ext cx="2377440" cy="310896"/>
+          </a:xfrm>
+          <a:prstGeom prst="rect">
+            <a:avLst/>
+          </a:prstGeom>
+          <a:noFill/>
+          <a:ln/>
+        </p:spPr>
+        <p:txBody>
+          <a:bodyPr wrap="square" lIns="0" tIns="0" rIns="0" bIns="0" rtlCol="0" anchor="ctr"/>
+          <a:lstStyle/>
+          <a:p>
+            <a:pPr indent="0" marL="0">
+              <a:buNone/>
+            </a:pPr>
+            <a:r>
+              <a:rPr lang="en-US" sz="1700" dirty="0">
+                <a:solidFill>
+                  <a:schemeClr val="tx1"/>
+                </a:solidFill>
+              </a:rPr>
+              <a:t>Its stock is protected</a:t>
+            </a:r>
+            <a:endParaRPr lang="en-US" sz="1700" dirty="0"/>
+          </a:p>
+        </p:txBody>
+      </p:sp>
+      <p:sp>
+        <p:nvSpPr>
+          <p:cNvPr id="15" name="Shape 13"/>
+          <p:cNvSpPr/>
+          <p:nvPr/>
+        </p:nvSpPr>
+        <p:spPr>
+          <a:xfrm>
+            <a:off x="6080760" y="4279392"/>
+            <a:ext cx="109728" cy="109728"/>
+          </a:xfrm>
+          <a:prstGeom prst="ellipse">
+            <a:avLst/>
+          </a:prstGeom>
+          <a:solidFill>
+            <a:schemeClr val="accent1"/>
+          </a:solidFill>
+          <a:ln/>
+        </p:spPr>
+      </p:sp>
+      <p:sp>
+        <p:nvSpPr>
+          <p:cNvPr id="16" name="Text 14"/>
+          <p:cNvSpPr txBox="1"/>
+          <p:nvPr/>
+        </p:nvSpPr>
+        <p:spPr>
+          <a:xfrm>
+            <a:off x="6327648" y="4178808"/>
+            <a:ext cx="2377440" cy="310896"/>
+          </a:xfrm>
+          <a:prstGeom prst="rect">
+            <a:avLst/>
+          </a:prstGeom>
+          <a:noFill/>
+          <a:ln/>
+        </p:spPr>
+        <p:txBody>
+          <a:bodyPr wrap="square" lIns="0" tIns="0" rIns="0" bIns="0" rtlCol="0" anchor="ctr"/>
+          <a:lstStyle/>
+          <a:p>
+            <a:pPr indent="0" marL="0">
+              <a:buNone/>
+            </a:pPr>
+            <a:r>
+              <a:rPr lang="en-US" sz="1700" dirty="0">
+                <a:solidFill>
+                  <a:schemeClr val="tx1"/>
+                </a:solidFill>
+              </a:rPr>
+              <a:t>Alert: Recover now</a:t>
+            </a:r>
+            <a:endParaRPr lang="en-US" sz="1700" dirty="0"/>
+          </a:p>
+        </p:txBody>
+      </p:sp>
+      <p:pic>
+        <p:nvPicPr>
+          <p:cNvPr id="66" name="Screenshot 6" descr="Life-critical alert header, orders ranked by need, and a fix blocked because it would take a hospital order's stock"/>
+          <p:cNvPicPr>
+            <a:picLocks noChangeAspect="1"/>
+          </p:cNvPicPr>
+          <p:nvPr/>
+        </p:nvPicPr>
+        <p:blipFill>
+          <a:blip r:embed="rId2"/>
+          <a:stretch>
+            <a:fillRect/>
+          </a:stretch>
+        </p:blipFill>
+        <p:spPr>
+          <a:xfrm>
+            <a:off x="457200" y="2239742"/>
+            <a:ext cx="5257800" cy="2104196"/>
+          </a:xfrm>
+          <a:prstGeom prst="rect">
+            <a:avLst/>
+          </a:prstGeom>
+          <a:ln w="9525">
+            <a:solidFill>
+              <a:srgbClr val="BFBFBF"/>
+            </a:solidFill>
+          </a:ln>
+        </p:spPr>
+      </p:pic>
+      <p:sp>
+        <p:nvSpPr>
+          <p:cNvPr id="25" name="Slide Number Placeholder 0"/>
+          <p:cNvSpPr>
+            <a:spLocks noGrp="1"/>
+          </p:cNvSpPr>
+          <p:nvPr>
+            <p:ph type="sldNum" sz="quarter" idx="4294967295"/>
+          </p:nvPr>
+        </p:nvSpPr>
+        <p:spPr>
+          <a:xfrm>
+            <a:off x="8229600" y="4754880"/>
+            <a:ext cx="457200" cy="228600"/>
+          </a:xfrm>
+          <a:prstGeom prst="rect">
+            <a:avLst/>
+          </a:prstGeom>
+          <a:extLst>
+            <a:ext uri="{C572A759-6A51-4108-AA02-DFA0A04FC94B}">
+              <ma14:wrappingTextBoxFlag xmlns:ma14="http://schemas.microsoft.com/office/mac/drawingml/2011/main" val="0"/>
+            </a:ext>
+          </a:extLst>
+        </p:spPr>
+        <p:txBody>
+          <a:bodyPr lIns="0" tIns="0" rIns="0" bIns="0" anchor="ctr"/>
+          <a:lstStyle>
+            <a:lvl1pPr>
+              <a:defRPr sz="1000">
+                <a:solidFill>
+                  <a:schemeClr val="accent2"/>
+                </a:solidFill>
+              </a:defRPr>
+            </a:lvl1pPr>
+          </a:lstStyle>
+          <a:p>
+            <a:pPr algn="r"/>
+            <a:fld id="{F7021451-1387-4CA6-816F-3879F97B5CBC}" type="slidenum">
+              <a:rPr b="0" lang="en-US"/>
+              <a:t>6</a:t>
             </a:fld>
             <a:endParaRPr lang="en-US"/>
           </a:p>

</xml_diff>